<commit_message>
Ground VP deck market references in the gas-power model v1
Slide 9 gains the PROVISIONAL-tagged market line the build prompt calls
for ($170-240M/yr gas-generation cable POs through 2030), and the
slide 2/9 speaker notes now cite the market model workbook and executive
readout with the evidence caveats. Structure unchanged: 9 main + 4
appendix per the build prompt.

Co-Authored-By: Claude Fable 5 <noreply@anthropic.com>
Claude-Session: https://claude.ai/code/session_014waJkKXdttVr7zZ4yitWrV
</commit_message>
<xml_diff>
--- a/deck/Southwire_PowerGen_ValueProp_Rev01.pptx
+++ b/deck/Southwire_PowerGen_ValueProp_Rev01.pptx
@@ -960,7 +960,7 @@
             <a:r>
               <a:rPr lang="en-US" dirty="0"/>
               <a:t>One paragraph per engagement. NRG: teaser delivered against their public program; site visit on the table; taught us to read an account's own numbers back to them. CPV: active development conversations; taught us how offtaker/PPA financing shapes what a developer will pay for. Southern Power: warm inbound at SVP level; taught us success stories open doors. The strategy pivot (OEM- and EPC-first) traces to real IPP feedback — they push execution risk to their EPCs — not a whiteboard.
-[Sources] July OEM quoting report (~$9.7M, quoting not bookings); engagement notes per account; market model is PROVISIONAL pending internal PO history and BOMs.</a:t>
+[Sources] July OEM quoting report (~$9.7M, quoting not bookings); engagement notes per account; market model is PROVISIONAL pending internal PO history and BOMs — US_Gas_Power_Wire_Cable_Market_Model_v1.xlsx (17 sheets, live formulas) with the executive readout, research cutoff Aug 27, 2026.</a:t>
             </a:r>
             <a:endParaRPr lang="en-US" dirty="0"/>
           </a:p>
@@ -1582,8 +1582,8 @@
           <a:p>
             <a:r>
               <a:rPr lang="en-US" dirty="0"/>
-              <a:t>Cadence proposal: this group reconvenes monthly for the first quarter, then quarterly; lane owners report against the asks on this slide. The 30-day strategy document (with BD) lands: validated market model (replacing the PROVISIONAL tag), lane plans with owners and dates, the agent-credit decision, and the utility funnel mechanics agreed with John's team.
-[Sources] Internal — roles per current org; asks trace to slides 5–8.</a:t>
+              <a:t>Cadence proposal: this group reconvenes monthly for the first quarter, then quarterly; lane owners report against the asks on this slide. The 30-day strategy document (with BD) lands: validated market model (replacing the PROVISIONAL tag), lane plans with owners and dates, the agent-credit decision, and the utility funnel mechanics agreed with John's team. The market line stays PROVISIONAL out loud: base case $170–240M per year in U.S. gas-generation cable POs through 2030 (constant 2026 dollars, manufacturer net sales, generation-side cable only), 2026 SAM ~$172M, cumulative 2026–35 SAM ~$1.0B — only 46% of named MW is evidence-backed and no internal quote/BOM/PO data is loaded, so no figure is presented as validated.
+[Sources] Internal — roles per current org; asks trace to slides 5–8. Market: US_Gas_Power_Wire_Cable_Market_Model_v1.xlsx (Executive_Summary, base scenario, PO-year view) and the gas-power executive readout (research cutoff Aug 27, 2026) — PROVISIONAL, model passes 27 QA tests with 3 disclosed exceptions.</a:t>
             </a:r>
             <a:endParaRPr lang="en-US" dirty="0"/>
           </a:p>
@@ -11938,6 +11938,88 @@
         </p:nvSpPr>
         <p:spPr>
           <a:xfrm>
+            <a:off x="6400800" y="5138928"/>
+            <a:ext cx="925373" cy="237744"/>
+          </a:xfrm>
+          <a:prstGeom prst="roundRect">
+            <a:avLst>
+              <a:gd name="adj" fmla="val 15385"/>
+            </a:avLst>
+          </a:prstGeom>
+          <a:solidFill>
+            <a:srgbClr val="C67A43"/>
+          </a:solidFill>
+          <a:ln/>
+        </p:spPr>
+        <p:txBody>
+          <a:bodyPr wrap="square" lIns="0" tIns="0" rIns="0" bIns="0" rtlCol="0" anchor="ctr"/>
+          <a:lstStyle/>
+          <a:p>
+            <a:pPr algn="ctr" indent="0" marL="0">
+              <a:buNone/>
+            </a:pPr>
+            <a:r>
+              <a:rPr lang="en-US" sz="800" b="1" spc="100" kern="0" dirty="0">
+                <a:solidFill>
+                  <a:srgbClr val="FFFFFF"/>
+                </a:solidFill>
+                <a:latin typeface="Arial" pitchFamily="34" charset="0"/>
+                <a:ea typeface="Arial" pitchFamily="34" charset="-122"/>
+                <a:cs typeface="Arial" pitchFamily="34" charset="-120"/>
+              </a:rPr>
+              <a:t>PROVISIONAL</a:t>
+            </a:r>
+            <a:endParaRPr lang="en-US" sz="800" dirty="0"/>
+          </a:p>
+        </p:txBody>
+      </p:sp>
+      <p:sp>
+        <p:nvSpPr>
+          <p:cNvPr id="29" name="Text 27"/>
+          <p:cNvSpPr txBox="1"/>
+          <p:nvPr/>
+        </p:nvSpPr>
+        <p:spPr>
+          <a:xfrm>
+            <a:off x="6400800" y="5440680"/>
+            <a:ext cx="5239512" cy="566928"/>
+          </a:xfrm>
+          <a:prstGeom prst="rect">
+            <a:avLst/>
+          </a:prstGeom>
+          <a:noFill/>
+          <a:ln/>
+        </p:spPr>
+        <p:txBody>
+          <a:bodyPr wrap="square" lIns="0" tIns="0" rIns="0" bIns="0" rtlCol="0" anchor="t"/>
+          <a:lstStyle/>
+          <a:p>
+            <a:pPr indent="0" marL="0">
+              <a:buNone/>
+            </a:pPr>
+            <a:r>
+              <a:rPr lang="en-US" sz="950" dirty="0">
+                <a:solidFill>
+                  <a:srgbClr val="A6ACB3"/>
+                </a:solidFill>
+                <a:latin typeface="Arial" pitchFamily="34" charset="0"/>
+                <a:ea typeface="Arial" pitchFamily="34" charset="-122"/>
+                <a:cs typeface="Arial" pitchFamily="34" charset="-120"/>
+              </a:rPr>
+              <a:t>Market behind the lanes: $170–240M a year in U.S. gas-generation cable POs through 2030 — model v1, awaiting internal PO history and BOMs.</a:t>
+            </a:r>
+            <a:endParaRPr lang="en-US" sz="950" dirty="0"/>
+          </a:p>
+        </p:txBody>
+      </p:sp>
+      <p:sp>
+        <p:nvSpPr>
+          <p:cNvPr id="30" name="Text 28"/>
+          <p:cNvSpPr txBox="1"/>
+          <p:nvPr/>
+        </p:nvSpPr>
+        <p:spPr>
+          <a:xfrm>
             <a:off x="548640" y="5806440"/>
             <a:ext cx="11091672" cy="411480"/>
           </a:xfrm>
@@ -11971,7 +12053,7 @@
       </p:sp>
       <p:sp>
         <p:nvSpPr>
-          <p:cNvPr id="29" name="Text 27"/>
+          <p:cNvPr id="31" name="Text 29"/>
           <p:cNvSpPr txBox="1"/>
           <p:nvPr/>
         </p:nvSpPr>
@@ -12010,7 +12092,7 @@
       </p:sp>
       <p:sp>
         <p:nvSpPr>
-          <p:cNvPr id="30" name="Text 28"/>
+          <p:cNvPr id="32" name="Text 30"/>
           <p:cNvSpPr txBox="1"/>
           <p:nvPr/>
         </p:nvSpPr>

</xml_diff>

<commit_message>
Restyle VP deck in Southwire brand colors with marketing signature
Southwire blue replaces copper as the sole working accent, deep navy
replaces graphite on dark slides, red reserved for the wordmark arc.
Adds the Southwire wordmark to the opener and closer and the 'We deliver
power... responsibly.' signature line to every footer. Structure,
content, and QA gates unchanged.

Co-Authored-By: Claude Fable 5 <noreply@anthropic.com>
Claude-Session: https://claude.ai/code/session_014waJkKXdttVr7zZ4yitWrV
</commit_message>
<xml_diff>
--- a/deck/Southwire_PowerGen_ValueProp_Rev01.pptx
+++ b/deck/Southwire_PowerGen_ValueProp_Rev01.pptx
@@ -1938,7 +1938,7 @@
     <p:bg>
       <p:bgPr>
         <a:solidFill>
-          <a:srgbClr val="1A1D21"/>
+          <a:srgbClr val="0C2340"/>
         </a:solidFill>
       </p:bgPr>
     </p:bg>
@@ -1983,7 +1983,7 @@
             <a:r>
               <a:rPr lang="en-US" sz="1050" b="1" spc="200" kern="0" dirty="0">
                 <a:solidFill>
-                  <a:srgbClr val="C67A43"/>
+                  <a:srgbClr val="6FA8DC"/>
                 </a:solidFill>
                 <a:latin typeface="Arial" pitchFamily="34" charset="0"/>
                 <a:ea typeface="Arial" pitchFamily="34" charset="-122"/>
@@ -1997,7 +1997,71 @@
       </p:sp>
       <p:sp>
         <p:nvSpPr>
-          <p:cNvPr id="3" name="Text 1"/>
+          <p:cNvPr id="3" name="Shape 1"/>
+          <p:cNvSpPr/>
+          <p:nvPr/>
+        </p:nvSpPr>
+        <p:spPr>
+          <a:xfrm>
+            <a:off x="10607040" y="237744"/>
+            <a:ext cx="384048" cy="274320"/>
+          </a:xfrm>
+          <a:prstGeom prst="arc">
+            <a:avLst>
+              <a:gd name="adj1" fmla="val 12000000"/>
+              <a:gd name="adj2" fmla="val 19800000"/>
+            </a:avLst>
+          </a:prstGeom>
+          <a:ln w="28575">
+            <a:solidFill>
+              <a:srgbClr val="E4322B"/>
+            </a:solidFill>
+            <a:prstDash val="solid"/>
+          </a:ln>
+        </p:spPr>
+      </p:sp>
+      <p:sp>
+        <p:nvSpPr>
+          <p:cNvPr id="4" name="Text 2"/>
+          <p:cNvSpPr txBox="1"/>
+          <p:nvPr/>
+        </p:nvSpPr>
+        <p:spPr>
+          <a:xfrm>
+            <a:off x="10104120" y="420624"/>
+            <a:ext cx="1554480" cy="310896"/>
+          </a:xfrm>
+          <a:prstGeom prst="rect">
+            <a:avLst/>
+          </a:prstGeom>
+          <a:noFill/>
+          <a:ln/>
+        </p:spPr>
+        <p:txBody>
+          <a:bodyPr wrap="square" lIns="0" tIns="0" rIns="0" bIns="0" rtlCol="0" anchor="ctr"/>
+          <a:lstStyle/>
+          <a:p>
+            <a:pPr algn="r" indent="0" marL="0">
+              <a:buNone/>
+            </a:pPr>
+            <a:r>
+              <a:rPr lang="en-US" sz="1400" b="1" dirty="0">
+                <a:solidFill>
+                  <a:srgbClr val="FFFFFF"/>
+                </a:solidFill>
+                <a:latin typeface="Arial" pitchFamily="34" charset="0"/>
+                <a:ea typeface="Arial" pitchFamily="34" charset="-122"/>
+                <a:cs typeface="Arial" pitchFamily="34" charset="-120"/>
+              </a:rPr>
+              <a:t>Southwire®</a:t>
+            </a:r>
+            <a:endParaRPr lang="en-US" sz="1400" dirty="0"/>
+          </a:p>
+        </p:txBody>
+      </p:sp>
+      <p:sp>
+        <p:nvSpPr>
+          <p:cNvPr id="5" name="Text 3"/>
           <p:cNvSpPr txBox="1"/>
           <p:nvPr/>
         </p:nvSpPr>
@@ -2036,7 +2100,7 @@
       </p:sp>
       <p:sp>
         <p:nvSpPr>
-          <p:cNvPr id="4" name="Shape 2"/>
+          <p:cNvPr id="6" name="Shape 4"/>
           <p:cNvSpPr/>
           <p:nvPr/>
         </p:nvSpPr>
@@ -2049,11 +2113,11 @@
             <a:avLst/>
           </a:prstGeom>
           <a:solidFill>
-            <a:srgbClr val="22262B"/>
+            <a:srgbClr val="14324F"/>
           </a:solidFill>
           <a:ln w="9525">
             <a:solidFill>
-              <a:srgbClr val="C67A43"/>
+              <a:srgbClr val="00539B"/>
             </a:solidFill>
             <a:prstDash val="dash"/>
           </a:ln>
@@ -2061,7 +2125,7 @@
       </p:sp>
       <p:sp>
         <p:nvSpPr>
-          <p:cNvPr id="5" name="Text 3"/>
+          <p:cNvPr id="7" name="Text 5"/>
           <p:cNvSpPr txBox="1"/>
           <p:nvPr/>
         </p:nvSpPr>
@@ -2086,7 +2150,7 @@
             <a:r>
               <a:rPr lang="en-US" sz="950" dirty="0">
                 <a:solidFill>
-                  <a:srgbClr val="A6ACB3"/>
+                  <a:srgbClr val="9FB4CC"/>
                 </a:solidFill>
                 <a:latin typeface="Arial" pitchFamily="34" charset="0"/>
                 <a:ea typeface="Arial" pitchFamily="34" charset="-122"/>
@@ -2103,7 +2167,7 @@
             <a:r>
               <a:rPr lang="en-US" sz="950" dirty="0">
                 <a:solidFill>
-                  <a:srgbClr val="A6ACB3"/>
+                  <a:srgbClr val="9FB4CC"/>
                 </a:solidFill>
                 <a:latin typeface="Arial" pitchFamily="34" charset="0"/>
                 <a:ea typeface="Arial" pitchFamily="34" charset="-122"/>
@@ -2117,7 +2181,7 @@
       </p:sp>
       <p:sp>
         <p:nvSpPr>
-          <p:cNvPr id="6" name="Text 4"/>
+          <p:cNvPr id="8" name="Text 6"/>
           <p:cNvSpPr txBox="1"/>
           <p:nvPr/>
         </p:nvSpPr>
@@ -2142,7 +2206,7 @@
             <a:r>
               <a:rPr lang="en-US" sz="950" dirty="0">
                 <a:solidFill>
-                  <a:srgbClr val="A6ACB3"/>
+                  <a:srgbClr val="9FB4CC"/>
                 </a:solidFill>
                 <a:latin typeface="Arial" pitchFamily="34" charset="0"/>
                 <a:ea typeface="Arial" pitchFamily="34" charset="-122"/>
@@ -2156,7 +2220,7 @@
       </p:sp>
       <p:sp>
         <p:nvSpPr>
-          <p:cNvPr id="7" name="Shape 5"/>
+          <p:cNvPr id="9" name="Shape 7"/>
           <p:cNvSpPr/>
           <p:nvPr/>
         </p:nvSpPr>
@@ -2169,11 +2233,11 @@
             <a:avLst/>
           </a:prstGeom>
           <a:solidFill>
-            <a:srgbClr val="22262B"/>
+            <a:srgbClr val="14324F"/>
           </a:solidFill>
           <a:ln w="9525">
             <a:solidFill>
-              <a:srgbClr val="C67A43"/>
+              <a:srgbClr val="00539B"/>
             </a:solidFill>
             <a:prstDash val="dash"/>
           </a:ln>
@@ -2181,7 +2245,7 @@
       </p:sp>
       <p:sp>
         <p:nvSpPr>
-          <p:cNvPr id="8" name="Text 6"/>
+          <p:cNvPr id="10" name="Text 8"/>
           <p:cNvSpPr txBox="1"/>
           <p:nvPr/>
         </p:nvSpPr>
@@ -2206,7 +2270,7 @@
             <a:r>
               <a:rPr lang="en-US" sz="950" dirty="0">
                 <a:solidFill>
-                  <a:srgbClr val="A6ACB3"/>
+                  <a:srgbClr val="9FB4CC"/>
                 </a:solidFill>
                 <a:latin typeface="Arial" pitchFamily="34" charset="0"/>
                 <a:ea typeface="Arial" pitchFamily="34" charset="-122"/>
@@ -2223,7 +2287,7 @@
             <a:r>
               <a:rPr lang="en-US" sz="950" dirty="0">
                 <a:solidFill>
-                  <a:srgbClr val="A6ACB3"/>
+                  <a:srgbClr val="9FB4CC"/>
                 </a:solidFill>
                 <a:latin typeface="Arial" pitchFamily="34" charset="0"/>
                 <a:ea typeface="Arial" pitchFamily="34" charset="-122"/>
@@ -2240,7 +2304,7 @@
             <a:r>
               <a:rPr lang="en-US" sz="950" dirty="0">
                 <a:solidFill>
-                  <a:srgbClr val="A6ACB3"/>
+                  <a:srgbClr val="9FB4CC"/>
                 </a:solidFill>
                 <a:latin typeface="Arial" pitchFamily="34" charset="0"/>
                 <a:ea typeface="Arial" pitchFamily="34" charset="-122"/>
@@ -2254,7 +2318,7 @@
       </p:sp>
       <p:sp>
         <p:nvSpPr>
-          <p:cNvPr id="9" name="Text 7"/>
+          <p:cNvPr id="11" name="Text 9"/>
           <p:cNvSpPr txBox="1"/>
           <p:nvPr/>
         </p:nvSpPr>
@@ -2279,7 +2343,7 @@
             <a:r>
               <a:rPr lang="en-US" sz="950" dirty="0">
                 <a:solidFill>
-                  <a:srgbClr val="A6ACB3"/>
+                  <a:srgbClr val="9FB4CC"/>
                 </a:solidFill>
                 <a:latin typeface="Arial" pitchFamily="34" charset="0"/>
                 <a:ea typeface="Arial" pitchFamily="34" charset="-122"/>
@@ -2293,7 +2357,7 @@
       </p:sp>
       <p:sp>
         <p:nvSpPr>
-          <p:cNvPr id="10" name="Shape 8"/>
+          <p:cNvPr id="12" name="Shape 10"/>
           <p:cNvSpPr/>
           <p:nvPr/>
         </p:nvSpPr>
@@ -2306,11 +2370,11 @@
             <a:avLst/>
           </a:prstGeom>
           <a:solidFill>
-            <a:srgbClr val="22262B"/>
+            <a:srgbClr val="14324F"/>
           </a:solidFill>
           <a:ln w="9525">
             <a:solidFill>
-              <a:srgbClr val="C67A43"/>
+              <a:srgbClr val="00539B"/>
             </a:solidFill>
             <a:prstDash val="dash"/>
           </a:ln>
@@ -2318,7 +2382,7 @@
       </p:sp>
       <p:sp>
         <p:nvSpPr>
-          <p:cNvPr id="11" name="Text 9"/>
+          <p:cNvPr id="13" name="Text 11"/>
           <p:cNvSpPr txBox="1"/>
           <p:nvPr/>
         </p:nvSpPr>
@@ -2343,7 +2407,7 @@
             <a:r>
               <a:rPr lang="en-US" sz="950" dirty="0">
                 <a:solidFill>
-                  <a:srgbClr val="A6ACB3"/>
+                  <a:srgbClr val="9FB4CC"/>
                 </a:solidFill>
                 <a:latin typeface="Arial" pitchFamily="34" charset="0"/>
                 <a:ea typeface="Arial" pitchFamily="34" charset="-122"/>
@@ -2360,7 +2424,7 @@
             <a:r>
               <a:rPr lang="en-US" sz="950" dirty="0">
                 <a:solidFill>
-                  <a:srgbClr val="A6ACB3"/>
+                  <a:srgbClr val="9FB4CC"/>
                 </a:solidFill>
                 <a:latin typeface="Arial" pitchFamily="34" charset="0"/>
                 <a:ea typeface="Arial" pitchFamily="34" charset="-122"/>
@@ -2374,7 +2438,7 @@
       </p:sp>
       <p:sp>
         <p:nvSpPr>
-          <p:cNvPr id="12" name="Text 10"/>
+          <p:cNvPr id="14" name="Text 12"/>
           <p:cNvSpPr txBox="1"/>
           <p:nvPr/>
         </p:nvSpPr>
@@ -2399,7 +2463,7 @@
             <a:r>
               <a:rPr lang="en-US" sz="950" dirty="0">
                 <a:solidFill>
-                  <a:srgbClr val="A6ACB3"/>
+                  <a:srgbClr val="9FB4CC"/>
                 </a:solidFill>
                 <a:latin typeface="Arial" pitchFamily="34" charset="0"/>
                 <a:ea typeface="Arial" pitchFamily="34" charset="-122"/>
@@ -2413,7 +2477,7 @@
       </p:sp>
       <p:sp>
         <p:nvSpPr>
-          <p:cNvPr id="13" name="Text 11"/>
+          <p:cNvPr id="15" name="Text 13"/>
           <p:cNvSpPr txBox="1"/>
           <p:nvPr/>
         </p:nvSpPr>
@@ -2438,7 +2502,7 @@
             <a:r>
               <a:rPr lang="en-US" sz="1800" b="1" dirty="0">
                 <a:solidFill>
-                  <a:srgbClr val="C67A43"/>
+                  <a:srgbClr val="6FA8DC"/>
                 </a:solidFill>
                 <a:latin typeface="Arial" pitchFamily="34" charset="0"/>
                 <a:ea typeface="Arial" pitchFamily="34" charset="-122"/>
@@ -2452,7 +2516,7 @@
       </p:sp>
       <p:sp>
         <p:nvSpPr>
-          <p:cNvPr id="14" name="Text 12"/>
+          <p:cNvPr id="16" name="Text 14"/>
           <p:cNvSpPr txBox="1"/>
           <p:nvPr/>
         </p:nvSpPr>
@@ -2477,7 +2541,7 @@
             <a:r>
               <a:rPr lang="en-US" sz="1800" b="1" dirty="0">
                 <a:solidFill>
-                  <a:srgbClr val="C67A43"/>
+                  <a:srgbClr val="6FA8DC"/>
                 </a:solidFill>
                 <a:latin typeface="Arial" pitchFamily="34" charset="0"/>
                 <a:ea typeface="Arial" pitchFamily="34" charset="-122"/>
@@ -2491,7 +2555,7 @@
       </p:sp>
       <p:sp>
         <p:nvSpPr>
-          <p:cNvPr id="15" name="Text 13"/>
+          <p:cNvPr id="17" name="Text 15"/>
           <p:cNvSpPr txBox="1"/>
           <p:nvPr/>
         </p:nvSpPr>
@@ -2516,7 +2580,7 @@
             <a:r>
               <a:rPr lang="en-US" sz="1500" b="1" dirty="0">
                 <a:solidFill>
-                  <a:srgbClr val="C67A43"/>
+                  <a:srgbClr val="6FA8DC"/>
                 </a:solidFill>
                 <a:latin typeface="Arial" pitchFamily="34" charset="0"/>
                 <a:ea typeface="Arial" pitchFamily="34" charset="-122"/>
@@ -2530,7 +2594,7 @@
       </p:sp>
       <p:sp>
         <p:nvSpPr>
-          <p:cNvPr id="16" name="Text 14"/>
+          <p:cNvPr id="18" name="Text 16"/>
           <p:cNvSpPr txBox="1"/>
           <p:nvPr/>
         </p:nvSpPr>
@@ -2569,7 +2633,7 @@
       </p:sp>
       <p:sp>
         <p:nvSpPr>
-          <p:cNvPr id="17" name="Text 15"/>
+          <p:cNvPr id="19" name="Text 17"/>
           <p:cNvSpPr txBox="1"/>
           <p:nvPr/>
         </p:nvSpPr>
@@ -2594,7 +2658,7 @@
             <a:r>
               <a:rPr lang="en-US" sz="1500" b="1" dirty="0">
                 <a:solidFill>
-                  <a:srgbClr val="C67A43"/>
+                  <a:srgbClr val="6FA8DC"/>
                 </a:solidFill>
                 <a:latin typeface="Arial" pitchFamily="34" charset="0"/>
                 <a:ea typeface="Arial" pitchFamily="34" charset="-122"/>
@@ -2608,7 +2672,7 @@
       </p:sp>
       <p:sp>
         <p:nvSpPr>
-          <p:cNvPr id="18" name="Text 16"/>
+          <p:cNvPr id="20" name="Text 18"/>
           <p:cNvSpPr txBox="1"/>
           <p:nvPr/>
         </p:nvSpPr>
@@ -2647,7 +2711,7 @@
       </p:sp>
       <p:sp>
         <p:nvSpPr>
-          <p:cNvPr id="19" name="Text 17"/>
+          <p:cNvPr id="21" name="Text 19"/>
           <p:cNvSpPr txBox="1"/>
           <p:nvPr/>
         </p:nvSpPr>
@@ -2672,7 +2736,7 @@
             <a:r>
               <a:rPr lang="en-US" sz="1500" b="1" dirty="0">
                 <a:solidFill>
-                  <a:srgbClr val="C67A43"/>
+                  <a:srgbClr val="6FA8DC"/>
                 </a:solidFill>
                 <a:latin typeface="Arial" pitchFamily="34" charset="0"/>
                 <a:ea typeface="Arial" pitchFamily="34" charset="-122"/>
@@ -2686,7 +2750,7 @@
       </p:sp>
       <p:sp>
         <p:nvSpPr>
-          <p:cNvPr id="20" name="Text 18"/>
+          <p:cNvPr id="22" name="Text 20"/>
           <p:cNvSpPr txBox="1"/>
           <p:nvPr/>
         </p:nvSpPr>
@@ -2725,7 +2789,7 @@
       </p:sp>
       <p:sp>
         <p:nvSpPr>
-          <p:cNvPr id="21" name="Text 19"/>
+          <p:cNvPr id="23" name="Text 21"/>
           <p:cNvSpPr txBox="1"/>
           <p:nvPr/>
         </p:nvSpPr>
@@ -2740,7 +2804,7 @@
             </a:avLst>
           </a:prstGeom>
           <a:solidFill>
-            <a:srgbClr val="C67A43"/>
+            <a:srgbClr val="00539B"/>
           </a:solidFill>
           <a:ln/>
         </p:spPr>
@@ -2768,7 +2832,7 @@
       </p:sp>
       <p:sp>
         <p:nvSpPr>
-          <p:cNvPr id="22" name="Text 20"/>
+          <p:cNvPr id="24" name="Text 22"/>
           <p:cNvSpPr txBox="1"/>
           <p:nvPr/>
         </p:nvSpPr>
@@ -2793,7 +2857,7 @@
             <a:r>
               <a:rPr lang="en-US" sz="850" i="1" dirty="0">
                 <a:solidFill>
-                  <a:srgbClr val="A6ACB3"/>
+                  <a:srgbClr val="9FB4CC"/>
                 </a:solidFill>
                 <a:latin typeface="Arial" pitchFamily="34" charset="0"/>
                 <a:ea typeface="Arial" pitchFamily="34" charset="-122"/>
@@ -2807,14 +2871,14 @@
       </p:sp>
       <p:sp>
         <p:nvSpPr>
-          <p:cNvPr id="23" name="Text 21"/>
+          <p:cNvPr id="25" name="Text 23"/>
           <p:cNvSpPr txBox="1"/>
           <p:nvPr/>
         </p:nvSpPr>
         <p:spPr>
           <a:xfrm>
             <a:off x="548640" y="6510528"/>
-            <a:ext cx="5029200" cy="237744"/>
+            <a:ext cx="3840480" cy="237744"/>
           </a:xfrm>
           <a:prstGeom prst="rect">
             <a:avLst/>
@@ -2832,7 +2896,7 @@
             <a:r>
               <a:rPr lang="en-US" sz="800" dirty="0">
                 <a:solidFill>
-                  <a:srgbClr val="8C9299"/>
+                  <a:srgbClr val="7E95AF"/>
                 </a:solidFill>
                 <a:latin typeface="Arial" pitchFamily="34" charset="0"/>
                 <a:ea typeface="Arial" pitchFamily="34" charset="-122"/>
@@ -2846,14 +2910,14 @@
       </p:sp>
       <p:sp>
         <p:nvSpPr>
-          <p:cNvPr id="24" name="Text 22"/>
-          <p:cNvSpPr txBox="1"/>
-          <p:nvPr/>
-        </p:nvSpPr>
-        <p:spPr>
-          <a:xfrm>
-            <a:off x="6583680" y="6510528"/>
-            <a:ext cx="5056632" cy="237744"/>
+          <p:cNvPr id="26" name="Text 24"/>
+          <p:cNvSpPr txBox="1"/>
+          <p:nvPr/>
+        </p:nvSpPr>
+        <p:spPr>
+          <a:xfrm>
+            <a:off x="4480560" y="6510528"/>
+            <a:ext cx="3227832" cy="237744"/>
           </a:xfrm>
           <a:prstGeom prst="rect">
             <a:avLst/>
@@ -2865,13 +2929,52 @@
           <a:bodyPr wrap="square" lIns="0" tIns="0" rIns="0" bIns="0" rtlCol="0" anchor="ctr"/>
           <a:lstStyle/>
           <a:p>
+            <a:pPr algn="ctr" indent="0" marL="0">
+              <a:buNone/>
+            </a:pPr>
+            <a:r>
+              <a:rPr lang="en-US" sz="800" i="1" dirty="0">
+                <a:solidFill>
+                  <a:srgbClr val="9FB4CC"/>
+                </a:solidFill>
+                <a:latin typeface="Arial" pitchFamily="34" charset="0"/>
+                <a:ea typeface="Arial" pitchFamily="34" charset="-122"/>
+                <a:cs typeface="Arial" pitchFamily="34" charset="-120"/>
+              </a:rPr>
+              <a:t>We deliver power… responsibly.®</a:t>
+            </a:r>
+            <a:endParaRPr lang="en-US" sz="800" dirty="0"/>
+          </a:p>
+        </p:txBody>
+      </p:sp>
+      <p:sp>
+        <p:nvSpPr>
+          <p:cNvPr id="27" name="Text 25"/>
+          <p:cNvSpPr txBox="1"/>
+          <p:nvPr/>
+        </p:nvSpPr>
+        <p:spPr>
+          <a:xfrm>
+            <a:off x="7799832" y="6510528"/>
+            <a:ext cx="3840480" cy="237744"/>
+          </a:xfrm>
+          <a:prstGeom prst="rect">
+            <a:avLst/>
+          </a:prstGeom>
+          <a:noFill/>
+          <a:ln/>
+        </p:spPr>
+        <p:txBody>
+          <a:bodyPr wrap="square" lIns="0" tIns="0" rIns="0" bIns="0" rtlCol="0" anchor="ctr"/>
+          <a:lstStyle/>
+          <a:p>
             <a:pPr algn="r" indent="0" marL="0">
               <a:buNone/>
             </a:pPr>
             <a:r>
               <a:rPr lang="en-US" sz="800" dirty="0">
                 <a:solidFill>
-                  <a:srgbClr val="8C9299"/>
+                  <a:srgbClr val="7E95AF"/>
                 </a:solidFill>
                 <a:latin typeface="Arial" pitchFamily="34" charset="0"/>
                 <a:ea typeface="Arial" pitchFamily="34" charset="-122"/>
@@ -2942,7 +3045,7 @@
             <a:r>
               <a:rPr lang="en-US" sz="1500" b="1" dirty="0">
                 <a:solidFill>
-                  <a:srgbClr val="1A1D21"/>
+                  <a:srgbClr val="0C2340"/>
                 </a:solidFill>
                 <a:latin typeface="Arial" pitchFamily="34" charset="0"/>
                 <a:ea typeface="Arial" pitchFamily="34" charset="-122"/>
@@ -2969,11 +3072,11 @@
             <a:avLst/>
           </a:prstGeom>
           <a:solidFill>
-            <a:srgbClr val="F1EEEA"/>
+            <a:srgbClr val="EDF2F7"/>
           </a:solidFill>
           <a:ln w="9525">
             <a:solidFill>
-              <a:srgbClr val="C67A43"/>
+              <a:srgbClr val="00539B"/>
             </a:solidFill>
             <a:prstDash val="dash"/>
           </a:ln>
@@ -3006,7 +3109,7 @@
             <a:r>
               <a:rPr lang="en-US" sz="950" dirty="0">
                 <a:solidFill>
-                  <a:srgbClr val="6B7075"/>
+                  <a:srgbClr val="5B6B7C"/>
                 </a:solidFill>
                 <a:latin typeface="Arial" pitchFamily="34" charset="0"/>
                 <a:ea typeface="Arial" pitchFamily="34" charset="-122"/>
@@ -3045,7 +3148,7 @@
             <a:r>
               <a:rPr lang="en-US" sz="850" dirty="0">
                 <a:solidFill>
-                  <a:srgbClr val="6B7075"/>
+                  <a:srgbClr val="5B6B7C"/>
                 </a:solidFill>
                 <a:latin typeface="Arial" pitchFamily="34" charset="0"/>
                 <a:ea typeface="Arial" pitchFamily="34" charset="-122"/>
@@ -3072,11 +3175,11 @@
             <a:avLst/>
           </a:prstGeom>
           <a:solidFill>
-            <a:srgbClr val="F1EEEA"/>
+            <a:srgbClr val="EDF2F7"/>
           </a:solidFill>
           <a:ln w="9525">
             <a:solidFill>
-              <a:srgbClr val="C67A43"/>
+              <a:srgbClr val="00539B"/>
             </a:solidFill>
             <a:prstDash val="dash"/>
           </a:ln>
@@ -3109,7 +3212,7 @@
             <a:r>
               <a:rPr lang="en-US" sz="950" dirty="0">
                 <a:solidFill>
-                  <a:srgbClr val="6B7075"/>
+                  <a:srgbClr val="5B6B7C"/>
                 </a:solidFill>
                 <a:latin typeface="Arial" pitchFamily="34" charset="0"/>
                 <a:ea typeface="Arial" pitchFamily="34" charset="-122"/>
@@ -3148,7 +3251,7 @@
             <a:r>
               <a:rPr lang="en-US" sz="850" dirty="0">
                 <a:solidFill>
-                  <a:srgbClr val="6B7075"/>
+                  <a:srgbClr val="5B6B7C"/>
                 </a:solidFill>
                 <a:latin typeface="Arial" pitchFamily="34" charset="0"/>
                 <a:ea typeface="Arial" pitchFamily="34" charset="-122"/>
@@ -3175,11 +3278,11 @@
             <a:avLst/>
           </a:prstGeom>
           <a:solidFill>
-            <a:srgbClr val="F1EEEA"/>
+            <a:srgbClr val="EDF2F7"/>
           </a:solidFill>
           <a:ln w="9525">
             <a:solidFill>
-              <a:srgbClr val="C67A43"/>
+              <a:srgbClr val="00539B"/>
             </a:solidFill>
             <a:prstDash val="dash"/>
           </a:ln>
@@ -3212,7 +3315,7 @@
             <a:r>
               <a:rPr lang="en-US" sz="950" dirty="0">
                 <a:solidFill>
-                  <a:srgbClr val="6B7075"/>
+                  <a:srgbClr val="5B6B7C"/>
                 </a:solidFill>
                 <a:latin typeface="Arial" pitchFamily="34" charset="0"/>
                 <a:ea typeface="Arial" pitchFamily="34" charset="-122"/>
@@ -3251,7 +3354,7 @@
             <a:r>
               <a:rPr lang="en-US" sz="850" dirty="0">
                 <a:solidFill>
-                  <a:srgbClr val="6B7075"/>
+                  <a:srgbClr val="5B6B7C"/>
                 </a:solidFill>
                 <a:latin typeface="Arial" pitchFamily="34" charset="0"/>
                 <a:ea typeface="Arial" pitchFamily="34" charset="-122"/>
@@ -3278,11 +3381,11 @@
             <a:avLst/>
           </a:prstGeom>
           <a:solidFill>
-            <a:srgbClr val="F1EEEA"/>
+            <a:srgbClr val="EDF2F7"/>
           </a:solidFill>
           <a:ln w="9525">
             <a:solidFill>
-              <a:srgbClr val="C67A43"/>
+              <a:srgbClr val="00539B"/>
             </a:solidFill>
             <a:prstDash val="dash"/>
           </a:ln>
@@ -3315,7 +3418,7 @@
             <a:r>
               <a:rPr lang="en-US" sz="950" dirty="0">
                 <a:solidFill>
-                  <a:srgbClr val="6B7075"/>
+                  <a:srgbClr val="5B6B7C"/>
                 </a:solidFill>
                 <a:latin typeface="Arial" pitchFamily="34" charset="0"/>
                 <a:ea typeface="Arial" pitchFamily="34" charset="-122"/>
@@ -3354,7 +3457,7 @@
             <a:r>
               <a:rPr lang="en-US" sz="850" dirty="0">
                 <a:solidFill>
-                  <a:srgbClr val="6B7075"/>
+                  <a:srgbClr val="5B6B7C"/>
                 </a:solidFill>
                 <a:latin typeface="Arial" pitchFamily="34" charset="0"/>
                 <a:ea typeface="Arial" pitchFamily="34" charset="-122"/>
@@ -3381,11 +3484,11 @@
             <a:avLst/>
           </a:prstGeom>
           <a:solidFill>
-            <a:srgbClr val="F1EEEA"/>
+            <a:srgbClr val="EDF2F7"/>
           </a:solidFill>
           <a:ln w="9525">
             <a:solidFill>
-              <a:srgbClr val="C67A43"/>
+              <a:srgbClr val="00539B"/>
             </a:solidFill>
             <a:prstDash val="dash"/>
           </a:ln>
@@ -3418,7 +3521,7 @@
             <a:r>
               <a:rPr lang="en-US" sz="950" dirty="0">
                 <a:solidFill>
-                  <a:srgbClr val="6B7075"/>
+                  <a:srgbClr val="5B6B7C"/>
                 </a:solidFill>
                 <a:latin typeface="Arial" pitchFamily="34" charset="0"/>
                 <a:ea typeface="Arial" pitchFamily="34" charset="-122"/>
@@ -3457,7 +3560,7 @@
             <a:r>
               <a:rPr lang="en-US" sz="850" dirty="0">
                 <a:solidFill>
-                  <a:srgbClr val="6B7075"/>
+                  <a:srgbClr val="5B6B7C"/>
                 </a:solidFill>
                 <a:latin typeface="Arial" pitchFamily="34" charset="0"/>
                 <a:ea typeface="Arial" pitchFamily="34" charset="-122"/>
@@ -3484,11 +3587,11 @@
             <a:avLst/>
           </a:prstGeom>
           <a:solidFill>
-            <a:srgbClr val="F1EEEA"/>
+            <a:srgbClr val="EDF2F7"/>
           </a:solidFill>
           <a:ln w="9525">
             <a:solidFill>
-              <a:srgbClr val="C67A43"/>
+              <a:srgbClr val="00539B"/>
             </a:solidFill>
             <a:prstDash val="dash"/>
           </a:ln>
@@ -3521,7 +3624,7 @@
             <a:r>
               <a:rPr lang="en-US" sz="950" dirty="0">
                 <a:solidFill>
-                  <a:srgbClr val="6B7075"/>
+                  <a:srgbClr val="5B6B7C"/>
                 </a:solidFill>
                 <a:latin typeface="Arial" pitchFamily="34" charset="0"/>
                 <a:ea typeface="Arial" pitchFamily="34" charset="-122"/>
@@ -3560,7 +3663,7 @@
             <a:r>
               <a:rPr lang="en-US" sz="850" dirty="0">
                 <a:solidFill>
-                  <a:srgbClr val="6B7075"/>
+                  <a:srgbClr val="5B6B7C"/>
                 </a:solidFill>
                 <a:latin typeface="Arial" pitchFamily="34" charset="0"/>
                 <a:ea typeface="Arial" pitchFamily="34" charset="-122"/>
@@ -3581,7 +3684,7 @@
         <p:spPr>
           <a:xfrm>
             <a:off x="548640" y="6510528"/>
-            <a:ext cx="5029200" cy="237744"/>
+            <a:ext cx="3840480" cy="237744"/>
           </a:xfrm>
           <a:prstGeom prst="rect">
             <a:avLst/>
@@ -3599,7 +3702,7 @@
             <a:r>
               <a:rPr lang="en-US" sz="800" dirty="0">
                 <a:solidFill>
-                  <a:srgbClr val="9A9FA4"/>
+                  <a:srgbClr val="8B99A8"/>
                 </a:solidFill>
                 <a:latin typeface="Arial" pitchFamily="34" charset="0"/>
                 <a:ea typeface="Arial" pitchFamily="34" charset="-122"/>
@@ -3619,8 +3722,8 @@
         </p:nvSpPr>
         <p:spPr>
           <a:xfrm>
-            <a:off x="6583680" y="6510528"/>
-            <a:ext cx="5056632" cy="237744"/>
+            <a:off x="4480560" y="6510528"/>
+            <a:ext cx="3227832" cy="237744"/>
           </a:xfrm>
           <a:prstGeom prst="rect">
             <a:avLst/>
@@ -3632,13 +3735,52 @@
           <a:bodyPr wrap="square" lIns="0" tIns="0" rIns="0" bIns="0" rtlCol="0" anchor="ctr"/>
           <a:lstStyle/>
           <a:p>
+            <a:pPr algn="ctr" indent="0" marL="0">
+              <a:buNone/>
+            </a:pPr>
+            <a:r>
+              <a:rPr lang="en-US" sz="800" i="1" dirty="0">
+                <a:solidFill>
+                  <a:srgbClr val="00539B"/>
+                </a:solidFill>
+                <a:latin typeface="Arial" pitchFamily="34" charset="0"/>
+                <a:ea typeface="Arial" pitchFamily="34" charset="-122"/>
+                <a:cs typeface="Arial" pitchFamily="34" charset="-120"/>
+              </a:rPr>
+              <a:t>We deliver power… responsibly.®</a:t>
+            </a:r>
+            <a:endParaRPr lang="en-US" sz="800" dirty="0"/>
+          </a:p>
+        </p:txBody>
+      </p:sp>
+      <p:sp>
+        <p:nvSpPr>
+          <p:cNvPr id="23" name="Text 21"/>
+          <p:cNvSpPr txBox="1"/>
+          <p:nvPr/>
+        </p:nvSpPr>
+        <p:spPr>
+          <a:xfrm>
+            <a:off x="7799832" y="6510528"/>
+            <a:ext cx="3840480" cy="237744"/>
+          </a:xfrm>
+          <a:prstGeom prst="rect">
+            <a:avLst/>
+          </a:prstGeom>
+          <a:noFill/>
+          <a:ln/>
+        </p:spPr>
+        <p:txBody>
+          <a:bodyPr wrap="square" lIns="0" tIns="0" rIns="0" bIns="0" rtlCol="0" anchor="ctr"/>
+          <a:lstStyle/>
+          <a:p>
             <a:pPr algn="r" indent="0" marL="0">
               <a:buNone/>
             </a:pPr>
             <a:r>
               <a:rPr lang="en-US" sz="800" dirty="0">
                 <a:solidFill>
-                  <a:srgbClr val="9A9FA4"/>
+                  <a:srgbClr val="8B99A8"/>
                 </a:solidFill>
                 <a:latin typeface="Arial" pitchFamily="34" charset="0"/>
                 <a:ea typeface="Arial" pitchFamily="34" charset="-122"/>
@@ -3709,7 +3851,7 @@
             <a:r>
               <a:rPr lang="en-US" sz="1500" b="1" dirty="0">
                 <a:solidFill>
-                  <a:srgbClr val="1A1D21"/>
+                  <a:srgbClr val="0C2340"/>
                 </a:solidFill>
                 <a:latin typeface="Arial" pitchFamily="34" charset="0"/>
                 <a:ea typeface="Arial" pitchFamily="34" charset="-122"/>
@@ -3736,11 +3878,11 @@
             <a:avLst/>
           </a:prstGeom>
           <a:solidFill>
-            <a:srgbClr val="F1EEEA"/>
+            <a:srgbClr val="EDF2F7"/>
           </a:solidFill>
           <a:ln w="9525">
             <a:solidFill>
-              <a:srgbClr val="C67A43"/>
+              <a:srgbClr val="00539B"/>
             </a:solidFill>
             <a:prstDash val="dash"/>
           </a:ln>
@@ -3773,7 +3915,7 @@
             <a:r>
               <a:rPr lang="en-US" sz="950" dirty="0">
                 <a:solidFill>
-                  <a:srgbClr val="6B7075"/>
+                  <a:srgbClr val="5B6B7C"/>
                 </a:solidFill>
                 <a:latin typeface="Arial" pitchFamily="34" charset="0"/>
                 <a:ea typeface="Arial" pitchFamily="34" charset="-122"/>
@@ -3794,7 +3936,7 @@
         <p:spPr>
           <a:xfrm>
             <a:off x="548640" y="6510528"/>
-            <a:ext cx="5029200" cy="237744"/>
+            <a:ext cx="3840480" cy="237744"/>
           </a:xfrm>
           <a:prstGeom prst="rect">
             <a:avLst/>
@@ -3812,7 +3954,7 @@
             <a:r>
               <a:rPr lang="en-US" sz="800" dirty="0">
                 <a:solidFill>
-                  <a:srgbClr val="9A9FA4"/>
+                  <a:srgbClr val="8B99A8"/>
                 </a:solidFill>
                 <a:latin typeface="Arial" pitchFamily="34" charset="0"/>
                 <a:ea typeface="Arial" pitchFamily="34" charset="-122"/>
@@ -3832,8 +3974,8 @@
         </p:nvSpPr>
         <p:spPr>
           <a:xfrm>
-            <a:off x="6583680" y="6510528"/>
-            <a:ext cx="5056632" cy="237744"/>
+            <a:off x="4480560" y="6510528"/>
+            <a:ext cx="3227832" cy="237744"/>
           </a:xfrm>
           <a:prstGeom prst="rect">
             <a:avLst/>
@@ -3845,13 +3987,52 @@
           <a:bodyPr wrap="square" lIns="0" tIns="0" rIns="0" bIns="0" rtlCol="0" anchor="ctr"/>
           <a:lstStyle/>
           <a:p>
+            <a:pPr algn="ctr" indent="0" marL="0">
+              <a:buNone/>
+            </a:pPr>
+            <a:r>
+              <a:rPr lang="en-US" sz="800" i="1" dirty="0">
+                <a:solidFill>
+                  <a:srgbClr val="00539B"/>
+                </a:solidFill>
+                <a:latin typeface="Arial" pitchFamily="34" charset="0"/>
+                <a:ea typeface="Arial" pitchFamily="34" charset="-122"/>
+                <a:cs typeface="Arial" pitchFamily="34" charset="-120"/>
+              </a:rPr>
+              <a:t>We deliver power… responsibly.®</a:t>
+            </a:r>
+            <a:endParaRPr lang="en-US" sz="800" dirty="0"/>
+          </a:p>
+        </p:txBody>
+      </p:sp>
+      <p:sp>
+        <p:nvSpPr>
+          <p:cNvPr id="7" name="Text 5"/>
+          <p:cNvSpPr txBox="1"/>
+          <p:nvPr/>
+        </p:nvSpPr>
+        <p:spPr>
+          <a:xfrm>
+            <a:off x="7799832" y="6510528"/>
+            <a:ext cx="3840480" cy="237744"/>
+          </a:xfrm>
+          <a:prstGeom prst="rect">
+            <a:avLst/>
+          </a:prstGeom>
+          <a:noFill/>
+          <a:ln/>
+        </p:spPr>
+        <p:txBody>
+          <a:bodyPr wrap="square" lIns="0" tIns="0" rIns="0" bIns="0" rtlCol="0" anchor="ctr"/>
+          <a:lstStyle/>
+          <a:p>
             <a:pPr algn="r" indent="0" marL="0">
               <a:buNone/>
             </a:pPr>
             <a:r>
               <a:rPr lang="en-US" sz="800" dirty="0">
                 <a:solidFill>
-                  <a:srgbClr val="9A9FA4"/>
+                  <a:srgbClr val="8B99A8"/>
                 </a:solidFill>
                 <a:latin typeface="Arial" pitchFamily="34" charset="0"/>
                 <a:ea typeface="Arial" pitchFamily="34" charset="-122"/>
@@ -3922,7 +4103,7 @@
             <a:r>
               <a:rPr lang="en-US" sz="1500" b="1" dirty="0">
                 <a:solidFill>
-                  <a:srgbClr val="1A1D21"/>
+                  <a:srgbClr val="0C2340"/>
                 </a:solidFill>
                 <a:latin typeface="Arial" pitchFamily="34" charset="0"/>
                 <a:ea typeface="Arial" pitchFamily="34" charset="-122"/>
@@ -3973,7 +4154,7 @@
                       <a:r>
                         <a:rPr lang="en-US" sz="1100" b="1" dirty="0">
                           <a:solidFill>
-                            <a:srgbClr val="C67A43"/>
+                            <a:srgbClr val="00539B"/>
                           </a:solidFill>
                           <a:latin typeface="Arial" pitchFamily="34" charset="0"/>
                           <a:ea typeface="Arial" pitchFamily="34" charset="-122"/>
@@ -4038,7 +4219,7 @@
                       <a:r>
                         <a:rPr lang="en-US" sz="1100" dirty="0">
                           <a:solidFill>
-                            <a:srgbClr val="1A1D21"/>
+                            <a:srgbClr val="0C2340"/>
                           </a:solidFill>
                           <a:latin typeface="Arial" pitchFamily="34" charset="0"/>
                           <a:ea typeface="Arial" pitchFamily="34" charset="-122"/>
@@ -4103,7 +4284,7 @@
                       <a:r>
                         <a:rPr lang="en-US" sz="1100" dirty="0">
                           <a:solidFill>
-                            <a:srgbClr val="6B7075"/>
+                            <a:srgbClr val="5B6B7C"/>
                           </a:solidFill>
                           <a:latin typeface="Arial" pitchFamily="34" charset="0"/>
                           <a:ea typeface="Arial" pitchFamily="34" charset="-122"/>
@@ -4170,7 +4351,7 @@
                       <a:r>
                         <a:rPr lang="en-US" sz="1100" b="1" dirty="0">
                           <a:solidFill>
-                            <a:srgbClr val="C67A43"/>
+                            <a:srgbClr val="00539B"/>
                           </a:solidFill>
                           <a:latin typeface="Arial" pitchFamily="34" charset="0"/>
                           <a:ea typeface="Arial" pitchFamily="34" charset="-122"/>
@@ -4235,7 +4416,7 @@
                       <a:r>
                         <a:rPr lang="en-US" sz="1100" dirty="0">
                           <a:solidFill>
-                            <a:srgbClr val="1A1D21"/>
+                            <a:srgbClr val="0C2340"/>
                           </a:solidFill>
                           <a:latin typeface="Arial" pitchFamily="34" charset="0"/>
                           <a:ea typeface="Arial" pitchFamily="34" charset="-122"/>
@@ -4300,7 +4481,7 @@
                       <a:r>
                         <a:rPr lang="en-US" sz="1100" dirty="0">
                           <a:solidFill>
-                            <a:srgbClr val="6B7075"/>
+                            <a:srgbClr val="5B6B7C"/>
                           </a:solidFill>
                           <a:latin typeface="Arial" pitchFamily="34" charset="0"/>
                           <a:ea typeface="Arial" pitchFamily="34" charset="-122"/>
@@ -4367,7 +4548,7 @@
                       <a:r>
                         <a:rPr lang="en-US" sz="1100" b="1" dirty="0">
                           <a:solidFill>
-                            <a:srgbClr val="C67A43"/>
+                            <a:srgbClr val="00539B"/>
                           </a:solidFill>
                           <a:latin typeface="Arial" pitchFamily="34" charset="0"/>
                           <a:ea typeface="Arial" pitchFamily="34" charset="-122"/>
@@ -4432,7 +4613,7 @@
                       <a:r>
                         <a:rPr lang="en-US" sz="1100" dirty="0">
                           <a:solidFill>
-                            <a:srgbClr val="1A1D21"/>
+                            <a:srgbClr val="0C2340"/>
                           </a:solidFill>
                           <a:latin typeface="Arial" pitchFamily="34" charset="0"/>
                           <a:ea typeface="Arial" pitchFamily="34" charset="-122"/>
@@ -4497,7 +4678,7 @@
                       <a:r>
                         <a:rPr lang="en-US" sz="1100" dirty="0">
                           <a:solidFill>
-                            <a:srgbClr val="6B7075"/>
+                            <a:srgbClr val="5B6B7C"/>
                           </a:solidFill>
                           <a:latin typeface="Arial" pitchFamily="34" charset="0"/>
                           <a:ea typeface="Arial" pitchFamily="34" charset="-122"/>
@@ -4564,7 +4745,7 @@
                       <a:r>
                         <a:rPr lang="en-US" sz="1100" b="1" dirty="0">
                           <a:solidFill>
-                            <a:srgbClr val="C67A43"/>
+                            <a:srgbClr val="00539B"/>
                           </a:solidFill>
                           <a:latin typeface="Arial" pitchFamily="34" charset="0"/>
                           <a:ea typeface="Arial" pitchFamily="34" charset="-122"/>
@@ -4629,7 +4810,7 @@
                       <a:r>
                         <a:rPr lang="en-US" sz="1100" dirty="0">
                           <a:solidFill>
-                            <a:srgbClr val="1A1D21"/>
+                            <a:srgbClr val="0C2340"/>
                           </a:solidFill>
                           <a:latin typeface="Arial" pitchFamily="34" charset="0"/>
                           <a:ea typeface="Arial" pitchFamily="34" charset="-122"/>
@@ -4694,7 +4875,7 @@
                       <a:r>
                         <a:rPr lang="en-US" sz="1100" dirty="0">
                           <a:solidFill>
-                            <a:srgbClr val="6B7075"/>
+                            <a:srgbClr val="5B6B7C"/>
                           </a:solidFill>
                           <a:latin typeface="Arial" pitchFamily="34" charset="0"/>
                           <a:ea typeface="Arial" pitchFamily="34" charset="-122"/>
@@ -4761,7 +4942,7 @@
                       <a:r>
                         <a:rPr lang="en-US" sz="1100" b="1" dirty="0">
                           <a:solidFill>
-                            <a:srgbClr val="C67A43"/>
+                            <a:srgbClr val="00539B"/>
                           </a:solidFill>
                           <a:latin typeface="Arial" pitchFamily="34" charset="0"/>
                           <a:ea typeface="Arial" pitchFamily="34" charset="-122"/>
@@ -4826,7 +5007,7 @@
                       <a:r>
                         <a:rPr lang="en-US" sz="1100" dirty="0">
                           <a:solidFill>
-                            <a:srgbClr val="1A1D21"/>
+                            <a:srgbClr val="0C2340"/>
                           </a:solidFill>
                           <a:latin typeface="Arial" pitchFamily="34" charset="0"/>
                           <a:ea typeface="Arial" pitchFamily="34" charset="-122"/>
@@ -4891,7 +5072,7 @@
                       <a:r>
                         <a:rPr lang="en-US" sz="1100" dirty="0">
                           <a:solidFill>
-                            <a:srgbClr val="6B7075"/>
+                            <a:srgbClr val="5B6B7C"/>
                           </a:solidFill>
                           <a:latin typeface="Arial" pitchFamily="34" charset="0"/>
                           <a:ea typeface="Arial" pitchFamily="34" charset="-122"/>
@@ -4958,7 +5139,7 @@
                       <a:r>
                         <a:rPr lang="en-US" sz="1100" b="1" dirty="0">
                           <a:solidFill>
-                            <a:srgbClr val="6B7075"/>
+                            <a:srgbClr val="5B6B7C"/>
                           </a:solidFill>
                           <a:latin typeface="Arial" pitchFamily="34" charset="0"/>
                           <a:ea typeface="Arial" pitchFamily="34" charset="-122"/>
@@ -5023,7 +5204,7 @@
                       <a:r>
                         <a:rPr lang="en-US" sz="1100" dirty="0">
                           <a:solidFill>
-                            <a:srgbClr val="1A1D21"/>
+                            <a:srgbClr val="0C2340"/>
                           </a:solidFill>
                           <a:latin typeface="Arial" pitchFamily="34" charset="0"/>
                           <a:ea typeface="Arial" pitchFamily="34" charset="-122"/>
@@ -5088,7 +5269,7 @@
                       <a:r>
                         <a:rPr lang="en-US" sz="1100" dirty="0">
                           <a:solidFill>
-                            <a:srgbClr val="6B7075"/>
+                            <a:srgbClr val="5B6B7C"/>
                           </a:solidFill>
                           <a:latin typeface="Arial" pitchFamily="34" charset="0"/>
                           <a:ea typeface="Arial" pitchFamily="34" charset="-122"/>
@@ -5155,7 +5336,7 @@
                       <a:r>
                         <a:rPr lang="en-US" sz="1100" b="1" dirty="0">
                           <a:solidFill>
-                            <a:srgbClr val="6B7075"/>
+                            <a:srgbClr val="5B6B7C"/>
                           </a:solidFill>
                           <a:latin typeface="Arial" pitchFamily="34" charset="0"/>
                           <a:ea typeface="Arial" pitchFamily="34" charset="-122"/>
@@ -5220,7 +5401,7 @@
                       <a:r>
                         <a:rPr lang="en-US" sz="1100" dirty="0">
                           <a:solidFill>
-                            <a:srgbClr val="1A1D21"/>
+                            <a:srgbClr val="0C2340"/>
                           </a:solidFill>
                           <a:latin typeface="Arial" pitchFamily="34" charset="0"/>
                           <a:ea typeface="Arial" pitchFamily="34" charset="-122"/>
@@ -5285,7 +5466,7 @@
                       <a:r>
                         <a:rPr lang="en-US" sz="1100" dirty="0">
                           <a:solidFill>
-                            <a:srgbClr val="6B7075"/>
+                            <a:srgbClr val="5B6B7C"/>
                           </a:solidFill>
                           <a:latin typeface="Arial" pitchFamily="34" charset="0"/>
                           <a:ea typeface="Arial" pitchFamily="34" charset="-122"/>
@@ -5352,7 +5533,7 @@
                       <a:r>
                         <a:rPr lang="en-US" sz="1100" b="1" dirty="0">
                           <a:solidFill>
-                            <a:srgbClr val="6B7075"/>
+                            <a:srgbClr val="5B6B7C"/>
                           </a:solidFill>
                           <a:latin typeface="Arial" pitchFamily="34" charset="0"/>
                           <a:ea typeface="Arial" pitchFamily="34" charset="-122"/>
@@ -5417,7 +5598,7 @@
                       <a:r>
                         <a:rPr lang="en-US" sz="1100" dirty="0">
                           <a:solidFill>
-                            <a:srgbClr val="1A1D21"/>
+                            <a:srgbClr val="0C2340"/>
                           </a:solidFill>
                           <a:latin typeface="Arial" pitchFamily="34" charset="0"/>
                           <a:ea typeface="Arial" pitchFamily="34" charset="-122"/>
@@ -5482,7 +5663,7 @@
                       <a:r>
                         <a:rPr lang="en-US" sz="1100" dirty="0">
                           <a:solidFill>
-                            <a:srgbClr val="6B7075"/>
+                            <a:srgbClr val="5B6B7C"/>
                           </a:solidFill>
                           <a:latin typeface="Arial" pitchFamily="34" charset="0"/>
                           <a:ea typeface="Arial" pitchFamily="34" charset="-122"/>
@@ -5550,7 +5731,7 @@
         <p:spPr>
           <a:xfrm>
             <a:off x="548640" y="6510528"/>
-            <a:ext cx="5029200" cy="237744"/>
+            <a:ext cx="3840480" cy="237744"/>
           </a:xfrm>
           <a:prstGeom prst="rect">
             <a:avLst/>
@@ -5568,7 +5749,7 @@
             <a:r>
               <a:rPr lang="en-US" sz="800" dirty="0">
                 <a:solidFill>
-                  <a:srgbClr val="9A9FA4"/>
+                  <a:srgbClr val="8B99A8"/>
                 </a:solidFill>
                 <a:latin typeface="Arial" pitchFamily="34" charset="0"/>
                 <a:ea typeface="Arial" pitchFamily="34" charset="-122"/>
@@ -5588,8 +5769,8 @@
         </p:nvSpPr>
         <p:spPr>
           <a:xfrm>
-            <a:off x="6583680" y="6510528"/>
-            <a:ext cx="5056632" cy="237744"/>
+            <a:off x="4480560" y="6510528"/>
+            <a:ext cx="3227832" cy="237744"/>
           </a:xfrm>
           <a:prstGeom prst="rect">
             <a:avLst/>
@@ -5601,13 +5782,52 @@
           <a:bodyPr wrap="square" lIns="0" tIns="0" rIns="0" bIns="0" rtlCol="0" anchor="ctr"/>
           <a:lstStyle/>
           <a:p>
+            <a:pPr algn="ctr" indent="0" marL="0">
+              <a:buNone/>
+            </a:pPr>
+            <a:r>
+              <a:rPr lang="en-US" sz="800" i="1" dirty="0">
+                <a:solidFill>
+                  <a:srgbClr val="00539B"/>
+                </a:solidFill>
+                <a:latin typeface="Arial" pitchFamily="34" charset="0"/>
+                <a:ea typeface="Arial" pitchFamily="34" charset="-122"/>
+                <a:cs typeface="Arial" pitchFamily="34" charset="-120"/>
+              </a:rPr>
+              <a:t>We deliver power… responsibly.®</a:t>
+            </a:r>
+            <a:endParaRPr lang="en-US" sz="800" dirty="0"/>
+          </a:p>
+        </p:txBody>
+      </p:sp>
+      <p:sp>
+        <p:nvSpPr>
+          <p:cNvPr id="6" name="Text 3"/>
+          <p:cNvSpPr txBox="1"/>
+          <p:nvPr/>
+        </p:nvSpPr>
+        <p:spPr>
+          <a:xfrm>
+            <a:off x="7799832" y="6510528"/>
+            <a:ext cx="3840480" cy="237744"/>
+          </a:xfrm>
+          <a:prstGeom prst="rect">
+            <a:avLst/>
+          </a:prstGeom>
+          <a:noFill/>
+          <a:ln/>
+        </p:spPr>
+        <p:txBody>
+          <a:bodyPr wrap="square" lIns="0" tIns="0" rIns="0" bIns="0" rtlCol="0" anchor="ctr"/>
+          <a:lstStyle/>
+          <a:p>
             <a:pPr algn="r" indent="0" marL="0">
               <a:buNone/>
             </a:pPr>
             <a:r>
               <a:rPr lang="en-US" sz="800" dirty="0">
                 <a:solidFill>
-                  <a:srgbClr val="9A9FA4"/>
+                  <a:srgbClr val="8B99A8"/>
                 </a:solidFill>
                 <a:latin typeface="Arial" pitchFamily="34" charset="0"/>
                 <a:ea typeface="Arial" pitchFamily="34" charset="-122"/>
@@ -5678,7 +5898,7 @@
             <a:r>
               <a:rPr lang="en-US" sz="1500" b="1" dirty="0">
                 <a:solidFill>
-                  <a:srgbClr val="1A1D21"/>
+                  <a:srgbClr val="0C2340"/>
                 </a:solidFill>
                 <a:latin typeface="Arial" pitchFamily="34" charset="0"/>
                 <a:ea typeface="Arial" pitchFamily="34" charset="-122"/>
@@ -5707,7 +5927,7 @@
             </a:avLst>
           </a:prstGeom>
           <a:solidFill>
-            <a:srgbClr val="C67A43"/>
+            <a:srgbClr val="00539B"/>
           </a:solidFill>
           <a:ln/>
         </p:spPr>
@@ -5760,7 +5980,7 @@
             <a:r>
               <a:rPr lang="en-US" sz="1500" b="1" dirty="0">
                 <a:solidFill>
-                  <a:srgbClr val="1A1D21"/>
+                  <a:srgbClr val="0C2340"/>
                 </a:solidFill>
                 <a:latin typeface="Arial" pitchFamily="34" charset="0"/>
                 <a:ea typeface="Arial" pitchFamily="34" charset="-122"/>
@@ -5799,7 +6019,7 @@
             <a:r>
               <a:rPr lang="en-US" sz="2600" b="1" dirty="0">
                 <a:solidFill>
-                  <a:srgbClr val="C67A43"/>
+                  <a:srgbClr val="00539B"/>
                 </a:solidFill>
                 <a:latin typeface="Arial" pitchFamily="34" charset="0"/>
                 <a:ea typeface="Arial" pitchFamily="34" charset="-122"/>
@@ -5826,7 +6046,7 @@
             <a:avLst/>
           </a:prstGeom>
           <a:solidFill>
-            <a:srgbClr val="C67A43"/>
+            <a:srgbClr val="00539B"/>
           </a:solidFill>
           <a:ln/>
         </p:spPr>
@@ -5858,7 +6078,7 @@
             <a:r>
               <a:rPr lang="en-US" sz="1300" dirty="0">
                 <a:solidFill>
-                  <a:srgbClr val="1A1D21"/>
+                  <a:srgbClr val="0C2340"/>
                 </a:solidFill>
                 <a:latin typeface="Arial" pitchFamily="34" charset="0"/>
                 <a:ea typeface="Arial" pitchFamily="34" charset="-122"/>
@@ -5885,7 +6105,7 @@
             <a:avLst/>
           </a:prstGeom>
           <a:solidFill>
-            <a:srgbClr val="C67A43"/>
+            <a:srgbClr val="00539B"/>
           </a:solidFill>
           <a:ln/>
         </p:spPr>
@@ -5917,7 +6137,7 @@
             <a:r>
               <a:rPr lang="en-US" sz="1300" dirty="0">
                 <a:solidFill>
-                  <a:srgbClr val="1A1D21"/>
+                  <a:srgbClr val="0C2340"/>
                 </a:solidFill>
                 <a:latin typeface="Arial" pitchFamily="34" charset="0"/>
                 <a:ea typeface="Arial" pitchFamily="34" charset="-122"/>
@@ -5944,7 +6164,7 @@
             <a:avLst/>
           </a:prstGeom>
           <a:solidFill>
-            <a:srgbClr val="F7EEE6"/>
+            <a:srgbClr val="EAF1F8"/>
           </a:solidFill>
           <a:ln/>
         </p:spPr>
@@ -5976,7 +6196,7 @@
             <a:r>
               <a:rPr lang="en-US" sz="850" b="1" spc="150" kern="0" dirty="0">
                 <a:solidFill>
-                  <a:srgbClr val="C67A43"/>
+                  <a:srgbClr val="00539B"/>
                 </a:solidFill>
                 <a:latin typeface="Arial" pitchFamily="34" charset="0"/>
                 <a:ea typeface="Arial" pitchFamily="34" charset="-122"/>
@@ -6015,7 +6235,7 @@
             <a:r>
               <a:rPr lang="en-US" sz="1150" dirty="0">
                 <a:solidFill>
-                  <a:srgbClr val="1A1D21"/>
+                  <a:srgbClr val="0C2340"/>
                 </a:solidFill>
                 <a:latin typeface="Arial" pitchFamily="34" charset="0"/>
                 <a:ea typeface="Arial" pitchFamily="34" charset="-122"/>
@@ -6036,7 +6256,7 @@
         <p:spPr>
           <a:xfrm>
             <a:off x="548640" y="6510528"/>
-            <a:ext cx="5029200" cy="237744"/>
+            <a:ext cx="3840480" cy="237744"/>
           </a:xfrm>
           <a:prstGeom prst="rect">
             <a:avLst/>
@@ -6054,7 +6274,7 @@
             <a:r>
               <a:rPr lang="en-US" sz="800" dirty="0">
                 <a:solidFill>
-                  <a:srgbClr val="9A9FA4"/>
+                  <a:srgbClr val="8B99A8"/>
                 </a:solidFill>
                 <a:latin typeface="Arial" pitchFamily="34" charset="0"/>
                 <a:ea typeface="Arial" pitchFamily="34" charset="-122"/>
@@ -6074,8 +6294,8 @@
         </p:nvSpPr>
         <p:spPr>
           <a:xfrm>
-            <a:off x="6583680" y="6510528"/>
-            <a:ext cx="5056632" cy="237744"/>
+            <a:off x="4480560" y="6510528"/>
+            <a:ext cx="3227832" cy="237744"/>
           </a:xfrm>
           <a:prstGeom prst="rect">
             <a:avLst/>
@@ -6087,13 +6307,52 @@
           <a:bodyPr wrap="square" lIns="0" tIns="0" rIns="0" bIns="0" rtlCol="0" anchor="ctr"/>
           <a:lstStyle/>
           <a:p>
+            <a:pPr algn="ctr" indent="0" marL="0">
+              <a:buNone/>
+            </a:pPr>
+            <a:r>
+              <a:rPr lang="en-US" sz="800" i="1" dirty="0">
+                <a:solidFill>
+                  <a:srgbClr val="00539B"/>
+                </a:solidFill>
+                <a:latin typeface="Arial" pitchFamily="34" charset="0"/>
+                <a:ea typeface="Arial" pitchFamily="34" charset="-122"/>
+                <a:cs typeface="Arial" pitchFamily="34" charset="-120"/>
+              </a:rPr>
+              <a:t>We deliver power… responsibly.®</a:t>
+            </a:r>
+            <a:endParaRPr lang="en-US" sz="800" dirty="0"/>
+          </a:p>
+        </p:txBody>
+      </p:sp>
+      <p:sp>
+        <p:nvSpPr>
+          <p:cNvPr id="15" name="Text 13"/>
+          <p:cNvSpPr txBox="1"/>
+          <p:nvPr/>
+        </p:nvSpPr>
+        <p:spPr>
+          <a:xfrm>
+            <a:off x="7799832" y="6510528"/>
+            <a:ext cx="3840480" cy="237744"/>
+          </a:xfrm>
+          <a:prstGeom prst="rect">
+            <a:avLst/>
+          </a:prstGeom>
+          <a:noFill/>
+          <a:ln/>
+        </p:spPr>
+        <p:txBody>
+          <a:bodyPr wrap="square" lIns="0" tIns="0" rIns="0" bIns="0" rtlCol="0" anchor="ctr"/>
+          <a:lstStyle/>
+          <a:p>
             <a:pPr algn="r" indent="0" marL="0">
               <a:buNone/>
             </a:pPr>
             <a:r>
               <a:rPr lang="en-US" sz="800" dirty="0">
                 <a:solidFill>
-                  <a:srgbClr val="9A9FA4"/>
+                  <a:srgbClr val="8B99A8"/>
                 </a:solidFill>
                 <a:latin typeface="Arial" pitchFamily="34" charset="0"/>
                 <a:ea typeface="Arial" pitchFamily="34" charset="-122"/>
@@ -6164,7 +6423,7 @@
             <a:r>
               <a:rPr lang="en-US" sz="1050" b="1" spc="200" kern="0" dirty="0">
                 <a:solidFill>
-                  <a:srgbClr val="C67A43"/>
+                  <a:srgbClr val="00539B"/>
                 </a:solidFill>
                 <a:latin typeface="Arial" pitchFamily="34" charset="0"/>
                 <a:ea typeface="Arial" pitchFamily="34" charset="-122"/>
@@ -6203,7 +6462,7 @@
             <a:r>
               <a:rPr lang="en-US" sz="3200" b="1" dirty="0">
                 <a:solidFill>
-                  <a:srgbClr val="1A1D21"/>
+                  <a:srgbClr val="0C2340"/>
                 </a:solidFill>
                 <a:latin typeface="Arial" pitchFamily="34" charset="0"/>
                 <a:ea typeface="Arial" pitchFamily="34" charset="-122"/>
@@ -6242,7 +6501,7 @@
             <a:r>
               <a:rPr lang="en-US" sz="1100" b="1" spc="150" kern="0" dirty="0">
                 <a:solidFill>
-                  <a:srgbClr val="C67A43"/>
+                  <a:srgbClr val="00539B"/>
                 </a:solidFill>
                 <a:latin typeface="Arial" pitchFamily="34" charset="0"/>
                 <a:ea typeface="Arial" pitchFamily="34" charset="-122"/>
@@ -6281,7 +6540,7 @@
             <a:r>
               <a:rPr lang="en-US" sz="1100" b="1" spc="150" kern="0" dirty="0">
                 <a:solidFill>
-                  <a:srgbClr val="C67A43"/>
+                  <a:srgbClr val="00539B"/>
                 </a:solidFill>
                 <a:latin typeface="Arial" pitchFamily="34" charset="0"/>
                 <a:ea typeface="Arial" pitchFamily="34" charset="-122"/>
@@ -6320,7 +6579,7 @@
             <a:r>
               <a:rPr lang="en-US" sz="1100" b="1" spc="150" kern="0" dirty="0">
                 <a:solidFill>
-                  <a:srgbClr val="C67A43"/>
+                  <a:srgbClr val="00539B"/>
                 </a:solidFill>
                 <a:latin typeface="Arial" pitchFamily="34" charset="0"/>
                 <a:ea typeface="Arial" pitchFamily="34" charset="-122"/>
@@ -6347,7 +6606,7 @@
             <a:avLst/>
           </a:prstGeom>
           <a:solidFill>
-            <a:srgbClr val="F5F4F2"/>
+            <a:srgbClr val="EFF3F7"/>
           </a:solidFill>
           <a:ln/>
         </p:spPr>
@@ -6382,7 +6641,7 @@
             <a:r>
               <a:rPr lang="en-US" sz="1250" dirty="0">
                 <a:solidFill>
-                  <a:srgbClr val="1A1D21"/>
+                  <a:srgbClr val="0C2340"/>
                 </a:solidFill>
                 <a:latin typeface="Arial" pitchFamily="34" charset="0"/>
                 <a:ea typeface="Arial" pitchFamily="34" charset="-122"/>
@@ -6402,7 +6661,7 @@
             <a:r>
               <a:rPr lang="en-US" sz="1250" dirty="0">
                 <a:solidFill>
-                  <a:srgbClr val="1A1D21"/>
+                  <a:srgbClr val="0C2340"/>
                 </a:solidFill>
                 <a:latin typeface="Arial" pitchFamily="34" charset="0"/>
                 <a:ea typeface="Arial" pitchFamily="34" charset="-122"/>
@@ -6422,7 +6681,7 @@
             <a:r>
               <a:rPr lang="en-US" sz="1250" dirty="0">
                 <a:solidFill>
-                  <a:srgbClr val="1A1D21"/>
+                  <a:srgbClr val="0C2340"/>
                 </a:solidFill>
                 <a:latin typeface="Arial" pitchFamily="34" charset="0"/>
                 <a:ea typeface="Arial" pitchFamily="34" charset="-122"/>
@@ -6442,7 +6701,7 @@
             <a:r>
               <a:rPr lang="en-US" sz="1250" dirty="0">
                 <a:solidFill>
-                  <a:srgbClr val="1A1D21"/>
+                  <a:srgbClr val="0C2340"/>
                 </a:solidFill>
                 <a:latin typeface="Arial" pitchFamily="34" charset="0"/>
                 <a:ea typeface="Arial" pitchFamily="34" charset="-122"/>
@@ -6469,7 +6728,7 @@
             <a:avLst/>
           </a:prstGeom>
           <a:solidFill>
-            <a:srgbClr val="F5F4F2"/>
+            <a:srgbClr val="EFF3F7"/>
           </a:solidFill>
           <a:ln/>
         </p:spPr>
@@ -6501,7 +6760,7 @@
             <a:r>
               <a:rPr lang="en-US" sz="900" b="1" spc="150" kern="0" dirty="0">
                 <a:solidFill>
-                  <a:srgbClr val="6B7075"/>
+                  <a:srgbClr val="5B6B7C"/>
                 </a:solidFill>
                 <a:latin typeface="Arial" pitchFamily="34" charset="0"/>
                 <a:ea typeface="Arial" pitchFamily="34" charset="-122"/>
@@ -6530,7 +6789,7 @@
             </a:avLst>
           </a:prstGeom>
           <a:solidFill>
-            <a:srgbClr val="C67A43"/>
+            <a:srgbClr val="00539B"/>
           </a:solidFill>
           <a:ln/>
         </p:spPr>
@@ -6583,7 +6842,7 @@
             <a:r>
               <a:rPr lang="en-US" sz="1050" dirty="0">
                 <a:solidFill>
-                  <a:srgbClr val="1A1D21"/>
+                  <a:srgbClr val="0C2340"/>
                 </a:solidFill>
                 <a:latin typeface="Arial" pitchFamily="34" charset="0"/>
                 <a:ea typeface="Arial" pitchFamily="34" charset="-122"/>
@@ -6610,7 +6869,7 @@
             <a:avLst/>
           </a:prstGeom>
           <a:solidFill>
-            <a:srgbClr val="F5F4F2"/>
+            <a:srgbClr val="EFF3F7"/>
           </a:solidFill>
           <a:ln/>
         </p:spPr>
@@ -6642,7 +6901,7 @@
             <a:r>
               <a:rPr lang="en-US" sz="900" b="1" spc="150" kern="0" dirty="0">
                 <a:solidFill>
-                  <a:srgbClr val="6B7075"/>
+                  <a:srgbClr val="5B6B7C"/>
                 </a:solidFill>
                 <a:latin typeface="Arial" pitchFamily="34" charset="0"/>
                 <a:ea typeface="Arial" pitchFamily="34" charset="-122"/>
@@ -6684,7 +6943,7 @@
             <a:r>
               <a:rPr lang="en-US" sz="1050" dirty="0">
                 <a:solidFill>
-                  <a:srgbClr val="1A1D21"/>
+                  <a:srgbClr val="0C2340"/>
                 </a:solidFill>
                 <a:latin typeface="Arial" pitchFamily="34" charset="0"/>
                 <a:ea typeface="Arial" pitchFamily="34" charset="-122"/>
@@ -6704,7 +6963,7 @@
             <a:r>
               <a:rPr lang="en-US" sz="1050" dirty="0">
                 <a:solidFill>
-                  <a:srgbClr val="1A1D21"/>
+                  <a:srgbClr val="0C2340"/>
                 </a:solidFill>
                 <a:latin typeface="Arial" pitchFamily="34" charset="0"/>
                 <a:ea typeface="Arial" pitchFamily="34" charset="-122"/>
@@ -6724,7 +6983,7 @@
             <a:r>
               <a:rPr lang="en-US" sz="1050" dirty="0">
                 <a:solidFill>
-                  <a:srgbClr val="1A1D21"/>
+                  <a:srgbClr val="0C2340"/>
                 </a:solidFill>
                 <a:latin typeface="Arial" pitchFamily="34" charset="0"/>
                 <a:ea typeface="Arial" pitchFamily="34" charset="-122"/>
@@ -6751,7 +7010,7 @@
             <a:avLst/>
           </a:prstGeom>
           <a:solidFill>
-            <a:srgbClr val="F5F4F2"/>
+            <a:srgbClr val="EFF3F7"/>
           </a:solidFill>
           <a:ln/>
         </p:spPr>
@@ -6786,7 +7045,7 @@
             <a:r>
               <a:rPr lang="en-US" sz="1150" dirty="0">
                 <a:solidFill>
-                  <a:srgbClr val="1A1D21"/>
+                  <a:srgbClr val="0C2340"/>
                 </a:solidFill>
                 <a:latin typeface="Arial" pitchFamily="34" charset="0"/>
                 <a:ea typeface="Arial" pitchFamily="34" charset="-122"/>
@@ -6806,7 +7065,7 @@
             <a:r>
               <a:rPr lang="en-US" sz="1150" dirty="0">
                 <a:solidFill>
-                  <a:srgbClr val="1A1D21"/>
+                  <a:srgbClr val="0C2340"/>
                 </a:solidFill>
                 <a:latin typeface="Arial" pitchFamily="34" charset="0"/>
                 <a:ea typeface="Arial" pitchFamily="34" charset="-122"/>
@@ -6826,7 +7085,7 @@
             <a:r>
               <a:rPr lang="en-US" sz="1150" dirty="0">
                 <a:solidFill>
-                  <a:srgbClr val="1A1D21"/>
+                  <a:srgbClr val="0C2340"/>
                 </a:solidFill>
                 <a:latin typeface="Arial" pitchFamily="34" charset="0"/>
                 <a:ea typeface="Arial" pitchFamily="34" charset="-122"/>
@@ -6846,7 +7105,7 @@
             <a:r>
               <a:rPr lang="en-US" sz="1150" dirty="0">
                 <a:solidFill>
-                  <a:srgbClr val="1A1D21"/>
+                  <a:srgbClr val="0C2340"/>
                 </a:solidFill>
                 <a:latin typeface="Arial" pitchFamily="34" charset="0"/>
                 <a:ea typeface="Arial" pitchFamily="34" charset="-122"/>
@@ -6873,7 +7132,7 @@
             <a:avLst/>
           </a:prstGeom>
           <a:solidFill>
-            <a:srgbClr val="C67A43"/>
+            <a:srgbClr val="00539B"/>
           </a:solidFill>
           <a:ln/>
         </p:spPr>
@@ -6905,7 +7164,7 @@
             <a:r>
               <a:rPr lang="en-US" sz="850" b="1" spc="150" kern="0" dirty="0">
                 <a:solidFill>
-                  <a:srgbClr val="F6E3D3"/>
+                  <a:srgbClr val="CFE0F2"/>
                 </a:solidFill>
                 <a:latin typeface="Arial" pitchFamily="34" charset="0"/>
                 <a:ea typeface="Arial" pitchFamily="34" charset="-122"/>
@@ -6965,7 +7224,7 @@
         <p:spPr>
           <a:xfrm>
             <a:off x="548640" y="6510528"/>
-            <a:ext cx="5029200" cy="237744"/>
+            <a:ext cx="3840480" cy="237744"/>
           </a:xfrm>
           <a:prstGeom prst="rect">
             <a:avLst/>
@@ -6983,7 +7242,7 @@
             <a:r>
               <a:rPr lang="en-US" sz="800" dirty="0">
                 <a:solidFill>
-                  <a:srgbClr val="9A9FA4"/>
+                  <a:srgbClr val="8B99A8"/>
                 </a:solidFill>
                 <a:latin typeface="Arial" pitchFamily="34" charset="0"/>
                 <a:ea typeface="Arial" pitchFamily="34" charset="-122"/>
@@ -7003,8 +7262,8 @@
         </p:nvSpPr>
         <p:spPr>
           <a:xfrm>
-            <a:off x="6583680" y="6510528"/>
-            <a:ext cx="5056632" cy="237744"/>
+            <a:off x="4480560" y="6510528"/>
+            <a:ext cx="3227832" cy="237744"/>
           </a:xfrm>
           <a:prstGeom prst="rect">
             <a:avLst/>
@@ -7016,13 +7275,52 @@
           <a:bodyPr wrap="square" lIns="0" tIns="0" rIns="0" bIns="0" rtlCol="0" anchor="ctr"/>
           <a:lstStyle/>
           <a:p>
+            <a:pPr algn="ctr" indent="0" marL="0">
+              <a:buNone/>
+            </a:pPr>
+            <a:r>
+              <a:rPr lang="en-US" sz="800" i="1" dirty="0">
+                <a:solidFill>
+                  <a:srgbClr val="00539B"/>
+                </a:solidFill>
+                <a:latin typeface="Arial" pitchFamily="34" charset="0"/>
+                <a:ea typeface="Arial" pitchFamily="34" charset="-122"/>
+                <a:cs typeface="Arial" pitchFamily="34" charset="-120"/>
+              </a:rPr>
+              <a:t>We deliver power… responsibly.®</a:t>
+            </a:r>
+            <a:endParaRPr lang="en-US" sz="800" dirty="0"/>
+          </a:p>
+        </p:txBody>
+      </p:sp>
+      <p:sp>
+        <p:nvSpPr>
+          <p:cNvPr id="23" name="Text 21"/>
+          <p:cNvSpPr txBox="1"/>
+          <p:nvPr/>
+        </p:nvSpPr>
+        <p:spPr>
+          <a:xfrm>
+            <a:off x="7799832" y="6510528"/>
+            <a:ext cx="3840480" cy="237744"/>
+          </a:xfrm>
+          <a:prstGeom prst="rect">
+            <a:avLst/>
+          </a:prstGeom>
+          <a:noFill/>
+          <a:ln/>
+        </p:spPr>
+        <p:txBody>
+          <a:bodyPr wrap="square" lIns="0" tIns="0" rIns="0" bIns="0" rtlCol="0" anchor="ctr"/>
+          <a:lstStyle/>
+          <a:p>
             <a:pPr algn="r" indent="0" marL="0">
               <a:buNone/>
             </a:pPr>
             <a:r>
               <a:rPr lang="en-US" sz="800" dirty="0">
                 <a:solidFill>
-                  <a:srgbClr val="9A9FA4"/>
+                  <a:srgbClr val="8B99A8"/>
                 </a:solidFill>
                 <a:latin typeface="Arial" pitchFamily="34" charset="0"/>
                 <a:ea typeface="Arial" pitchFamily="34" charset="-122"/>
@@ -7093,7 +7391,7 @@
             <a:r>
               <a:rPr lang="en-US" sz="1050" b="1" spc="200" kern="0" dirty="0">
                 <a:solidFill>
-                  <a:srgbClr val="C67A43"/>
+                  <a:srgbClr val="00539B"/>
                 </a:solidFill>
                 <a:latin typeface="Arial" pitchFamily="34" charset="0"/>
                 <a:ea typeface="Arial" pitchFamily="34" charset="-122"/>
@@ -7132,7 +7430,7 @@
             <a:r>
               <a:rPr lang="en-US" sz="2800" b="1" dirty="0">
                 <a:solidFill>
-                  <a:srgbClr val="1A1D21"/>
+                  <a:srgbClr val="0C2340"/>
                 </a:solidFill>
                 <a:latin typeface="Arial" pitchFamily="34" charset="0"/>
                 <a:ea typeface="Arial" pitchFamily="34" charset="-122"/>
@@ -7159,11 +7457,11 @@
             <a:avLst/>
           </a:prstGeom>
           <a:solidFill>
-            <a:srgbClr val="FDF8F3"/>
+            <a:srgbClr val="F1F6FB"/>
           </a:solidFill>
           <a:ln w="25400">
             <a:solidFill>
-              <a:srgbClr val="C67A43"/>
+              <a:srgbClr val="00539B"/>
             </a:solidFill>
             <a:prstDash val="solid"/>
           </a:ln>
@@ -7196,7 +7494,7 @@
             <a:r>
               <a:rPr lang="en-US" sz="1000" b="1" spc="150" kern="0" dirty="0">
                 <a:solidFill>
-                  <a:srgbClr val="C67A43"/>
+                  <a:srgbClr val="00539B"/>
                 </a:solidFill>
                 <a:latin typeface="Arial" pitchFamily="34" charset="0"/>
                 <a:ea typeface="Arial" pitchFamily="34" charset="-122"/>
@@ -7227,7 +7525,7 @@
           </a:solidFill>
           <a:ln w="12700">
             <a:solidFill>
-              <a:srgbClr val="C67A43"/>
+              <a:srgbClr val="00539B"/>
             </a:solidFill>
             <a:prstDash val="solid"/>
           </a:ln>
@@ -7260,7 +7558,7 @@
             <a:r>
               <a:rPr lang="en-US" sz="1050" dirty="0">
                 <a:solidFill>
-                  <a:srgbClr val="1A1D21"/>
+                  <a:srgbClr val="0C2340"/>
                 </a:solidFill>
                 <a:latin typeface="Arial" pitchFamily="34" charset="0"/>
                 <a:ea typeface="Arial" pitchFamily="34" charset="-122"/>
@@ -7291,7 +7589,7 @@
           </a:solidFill>
           <a:ln w="12700">
             <a:solidFill>
-              <a:srgbClr val="C67A43"/>
+              <a:srgbClr val="00539B"/>
             </a:solidFill>
             <a:prstDash val="solid"/>
           </a:ln>
@@ -7324,7 +7622,7 @@
             <a:r>
               <a:rPr lang="en-US" sz="1050" dirty="0">
                 <a:solidFill>
-                  <a:srgbClr val="1A1D21"/>
+                  <a:srgbClr val="0C2340"/>
                 </a:solidFill>
                 <a:latin typeface="Arial" pitchFamily="34" charset="0"/>
                 <a:ea typeface="Arial" pitchFamily="34" charset="-122"/>
@@ -7355,7 +7653,7 @@
           </a:solidFill>
           <a:ln w="12700">
             <a:solidFill>
-              <a:srgbClr val="C67A43"/>
+              <a:srgbClr val="00539B"/>
             </a:solidFill>
             <a:prstDash val="solid"/>
           </a:ln>
@@ -7388,7 +7686,7 @@
             <a:r>
               <a:rPr lang="en-US" sz="1050" dirty="0">
                 <a:solidFill>
-                  <a:srgbClr val="1A1D21"/>
+                  <a:srgbClr val="0C2340"/>
                 </a:solidFill>
                 <a:latin typeface="Arial" pitchFamily="34" charset="0"/>
                 <a:ea typeface="Arial" pitchFamily="34" charset="-122"/>
@@ -7419,7 +7717,7 @@
           </a:solidFill>
           <a:ln w="12700">
             <a:solidFill>
-              <a:srgbClr val="C67A43"/>
+              <a:srgbClr val="00539B"/>
             </a:solidFill>
             <a:prstDash val="solid"/>
           </a:ln>
@@ -7452,7 +7750,7 @@
             <a:r>
               <a:rPr lang="en-US" sz="1050" dirty="0">
                 <a:solidFill>
-                  <a:srgbClr val="1A1D21"/>
+                  <a:srgbClr val="0C2340"/>
                 </a:solidFill>
                 <a:latin typeface="Arial" pitchFamily="34" charset="0"/>
                 <a:ea typeface="Arial" pitchFamily="34" charset="-122"/>
@@ -7483,7 +7781,7 @@
           </a:solidFill>
           <a:ln w="12700">
             <a:solidFill>
-              <a:srgbClr val="C67A43"/>
+              <a:srgbClr val="00539B"/>
             </a:solidFill>
             <a:prstDash val="solid"/>
           </a:ln>
@@ -7516,7 +7814,7 @@
             <a:r>
               <a:rPr lang="en-US" sz="1050" dirty="0">
                 <a:solidFill>
-                  <a:srgbClr val="1A1D21"/>
+                  <a:srgbClr val="0C2340"/>
                 </a:solidFill>
                 <a:latin typeface="Arial" pitchFamily="34" charset="0"/>
                 <a:ea typeface="Arial" pitchFamily="34" charset="-122"/>
@@ -7555,7 +7853,7 @@
             <a:r>
               <a:rPr lang="en-US" sz="950" i="1" dirty="0">
                 <a:solidFill>
-                  <a:srgbClr val="6B7075"/>
+                  <a:srgbClr val="5B6B7C"/>
                 </a:solidFill>
                 <a:latin typeface="Arial" pitchFamily="34" charset="0"/>
                 <a:ea typeface="Arial" pitchFamily="34" charset="-122"/>
@@ -7584,7 +7882,7 @@
           <a:noFill/>
           <a:ln w="15875">
             <a:solidFill>
-              <a:srgbClr val="6B7075"/>
+              <a:srgbClr val="5B6B7C"/>
             </a:solidFill>
             <a:prstDash val="solid"/>
           </a:ln>
@@ -7609,7 +7907,7 @@
           </a:solidFill>
           <a:ln w="25400">
             <a:solidFill>
-              <a:srgbClr val="C67A43"/>
+              <a:srgbClr val="00539B"/>
             </a:solidFill>
             <a:prstDash val="solid"/>
           </a:ln>
@@ -7642,7 +7940,7 @@
             <a:r>
               <a:rPr lang="en-US" sz="1050" b="1" dirty="0">
                 <a:solidFill>
-                  <a:srgbClr val="C67A43"/>
+                  <a:srgbClr val="00539B"/>
                 </a:solidFill>
                 <a:latin typeface="Arial" pitchFamily="34" charset="0"/>
                 <a:ea typeface="Arial" pitchFamily="34" charset="-122"/>
@@ -7729,7 +8027,7 @@
             <a:r>
               <a:rPr lang="en-US" sz="1000" dirty="0">
                 <a:solidFill>
-                  <a:srgbClr val="6B7075"/>
+                  <a:srgbClr val="5B6B7C"/>
                 </a:solidFill>
                 <a:latin typeface="Arial" pitchFamily="34" charset="0"/>
                 <a:ea typeface="Arial" pitchFamily="34" charset="-122"/>
@@ -7768,7 +8066,7 @@
             <a:r>
               <a:rPr lang="en-US" sz="1100" dirty="0">
                 <a:solidFill>
-                  <a:srgbClr val="6B7075"/>
+                  <a:srgbClr val="5B6B7C"/>
                 </a:solidFill>
                 <a:latin typeface="Arial" pitchFamily="34" charset="0"/>
                 <a:ea typeface="Arial" pitchFamily="34" charset="-122"/>
@@ -7789,7 +8087,7 @@
         <p:spPr>
           <a:xfrm>
             <a:off x="548640" y="6510528"/>
-            <a:ext cx="5029200" cy="237744"/>
+            <a:ext cx="3840480" cy="237744"/>
           </a:xfrm>
           <a:prstGeom prst="rect">
             <a:avLst/>
@@ -7807,7 +8105,7 @@
             <a:r>
               <a:rPr lang="en-US" sz="800" dirty="0">
                 <a:solidFill>
-                  <a:srgbClr val="9A9FA4"/>
+                  <a:srgbClr val="8B99A8"/>
                 </a:solidFill>
                 <a:latin typeface="Arial" pitchFamily="34" charset="0"/>
                 <a:ea typeface="Arial" pitchFamily="34" charset="-122"/>
@@ -7827,8 +8125,8 @@
         </p:nvSpPr>
         <p:spPr>
           <a:xfrm>
-            <a:off x="6583680" y="6510528"/>
-            <a:ext cx="5056632" cy="237744"/>
+            <a:off x="4480560" y="6510528"/>
+            <a:ext cx="3227832" cy="237744"/>
           </a:xfrm>
           <a:prstGeom prst="rect">
             <a:avLst/>
@@ -7840,13 +8138,52 @@
           <a:bodyPr wrap="square" lIns="0" tIns="0" rIns="0" bIns="0" rtlCol="0" anchor="ctr"/>
           <a:lstStyle/>
           <a:p>
+            <a:pPr algn="ctr" indent="0" marL="0">
+              <a:buNone/>
+            </a:pPr>
+            <a:r>
+              <a:rPr lang="en-US" sz="800" i="1" dirty="0">
+                <a:solidFill>
+                  <a:srgbClr val="00539B"/>
+                </a:solidFill>
+                <a:latin typeface="Arial" pitchFamily="34" charset="0"/>
+                <a:ea typeface="Arial" pitchFamily="34" charset="-122"/>
+                <a:cs typeface="Arial" pitchFamily="34" charset="-120"/>
+              </a:rPr>
+              <a:t>We deliver power… responsibly.®</a:t>
+            </a:r>
+            <a:endParaRPr lang="en-US" sz="800" dirty="0"/>
+          </a:p>
+        </p:txBody>
+      </p:sp>
+      <p:sp>
+        <p:nvSpPr>
+          <p:cNvPr id="25" name="Text 23"/>
+          <p:cNvSpPr txBox="1"/>
+          <p:nvPr/>
+        </p:nvSpPr>
+        <p:spPr>
+          <a:xfrm>
+            <a:off x="7799832" y="6510528"/>
+            <a:ext cx="3840480" cy="237744"/>
+          </a:xfrm>
+          <a:prstGeom prst="rect">
+            <a:avLst/>
+          </a:prstGeom>
+          <a:noFill/>
+          <a:ln/>
+        </p:spPr>
+        <p:txBody>
+          <a:bodyPr wrap="square" lIns="0" tIns="0" rIns="0" bIns="0" rtlCol="0" anchor="ctr"/>
+          <a:lstStyle/>
+          <a:p>
             <a:pPr algn="r" indent="0" marL="0">
               <a:buNone/>
             </a:pPr>
             <a:r>
               <a:rPr lang="en-US" sz="800" dirty="0">
                 <a:solidFill>
-                  <a:srgbClr val="9A9FA4"/>
+                  <a:srgbClr val="8B99A8"/>
                 </a:solidFill>
                 <a:latin typeface="Arial" pitchFamily="34" charset="0"/>
                 <a:ea typeface="Arial" pitchFamily="34" charset="-122"/>
@@ -7872,7 +8209,7 @@
     <p:bg>
       <p:bgPr>
         <a:solidFill>
-          <a:srgbClr val="1A1D21"/>
+          <a:srgbClr val="0C2340"/>
         </a:solidFill>
       </p:bgPr>
     </p:bg>
@@ -7917,7 +8254,7 @@
             <a:r>
               <a:rPr lang="en-US" sz="1050" b="1" spc="200" kern="0" dirty="0">
                 <a:solidFill>
-                  <a:srgbClr val="C67A43"/>
+                  <a:srgbClr val="6FA8DC"/>
                 </a:solidFill>
                 <a:latin typeface="Arial" pitchFamily="34" charset="0"/>
                 <a:ea typeface="Arial" pitchFamily="34" charset="-122"/>
@@ -7983,7 +8320,7 @@
             <a:avLst/>
           </a:prstGeom>
           <a:solidFill>
-            <a:srgbClr val="C67A43"/>
+            <a:srgbClr val="6FA8DC"/>
           </a:solidFill>
           <a:ln/>
         </p:spPr>
@@ -8042,7 +8379,7 @@
             <a:avLst/>
           </a:prstGeom>
           <a:solidFill>
-            <a:srgbClr val="C67A43"/>
+            <a:srgbClr val="6FA8DC"/>
           </a:solidFill>
           <a:ln/>
         </p:spPr>
@@ -8101,7 +8438,7 @@
             <a:avLst/>
           </a:prstGeom>
           <a:solidFill>
-            <a:srgbClr val="C67A43"/>
+            <a:srgbClr val="6FA8DC"/>
           </a:solidFill>
           <a:ln/>
         </p:spPr>
@@ -8160,7 +8497,7 @@
             <a:avLst/>
           </a:prstGeom>
           <a:solidFill>
-            <a:srgbClr val="C67A43"/>
+            <a:srgbClr val="6FA8DC"/>
           </a:solidFill>
           <a:ln/>
         </p:spPr>
@@ -8219,7 +8556,7 @@
             <a:avLst/>
           </a:prstGeom>
           <a:solidFill>
-            <a:srgbClr val="C67A43"/>
+            <a:srgbClr val="6FA8DC"/>
           </a:solidFill>
           <a:ln/>
         </p:spPr>
@@ -8278,7 +8615,7 @@
             <a:avLst/>
           </a:prstGeom>
           <a:solidFill>
-            <a:srgbClr val="C67A43"/>
+            <a:srgbClr val="6FA8DC"/>
           </a:solidFill>
           <a:ln/>
         </p:spPr>
@@ -8339,7 +8676,7 @@
             </a:avLst>
           </a:prstGeom>
           <a:solidFill>
-            <a:srgbClr val="C67A43"/>
+            <a:srgbClr val="00539B"/>
           </a:solidFill>
           <a:ln/>
         </p:spPr>
@@ -8392,7 +8729,7 @@
             <a:r>
               <a:rPr lang="en-US" sz="1600" b="1" dirty="0">
                 <a:solidFill>
-                  <a:srgbClr val="C67A43"/>
+                  <a:srgbClr val="6FA8DC"/>
                 </a:solidFill>
                 <a:latin typeface="Arial" pitchFamily="34" charset="0"/>
                 <a:ea typeface="Arial" pitchFamily="34" charset="-122"/>
@@ -8413,7 +8750,7 @@
         <p:spPr>
           <a:xfrm>
             <a:off x="548640" y="6510528"/>
-            <a:ext cx="5029200" cy="237744"/>
+            <a:ext cx="3840480" cy="237744"/>
           </a:xfrm>
           <a:prstGeom prst="rect">
             <a:avLst/>
@@ -8431,7 +8768,7 @@
             <a:r>
               <a:rPr lang="en-US" sz="800" dirty="0">
                 <a:solidFill>
-                  <a:srgbClr val="8C9299"/>
+                  <a:srgbClr val="7E95AF"/>
                 </a:solidFill>
                 <a:latin typeface="Arial" pitchFamily="34" charset="0"/>
                 <a:ea typeface="Arial" pitchFamily="34" charset="-122"/>
@@ -8451,8 +8788,8 @@
         </p:nvSpPr>
         <p:spPr>
           <a:xfrm>
-            <a:off x="6583680" y="6510528"/>
-            <a:ext cx="5056632" cy="237744"/>
+            <a:off x="4480560" y="6510528"/>
+            <a:ext cx="3227832" cy="237744"/>
           </a:xfrm>
           <a:prstGeom prst="rect">
             <a:avLst/>
@@ -8464,13 +8801,52 @@
           <a:bodyPr wrap="square" lIns="0" tIns="0" rIns="0" bIns="0" rtlCol="0" anchor="ctr"/>
           <a:lstStyle/>
           <a:p>
+            <a:pPr algn="ctr" indent="0" marL="0">
+              <a:buNone/>
+            </a:pPr>
+            <a:r>
+              <a:rPr lang="en-US" sz="800" i="1" dirty="0">
+                <a:solidFill>
+                  <a:srgbClr val="9FB4CC"/>
+                </a:solidFill>
+                <a:latin typeface="Arial" pitchFamily="34" charset="0"/>
+                <a:ea typeface="Arial" pitchFamily="34" charset="-122"/>
+                <a:cs typeface="Arial" pitchFamily="34" charset="-120"/>
+              </a:rPr>
+              <a:t>We deliver power… responsibly.®</a:t>
+            </a:r>
+            <a:endParaRPr lang="en-US" sz="800" dirty="0"/>
+          </a:p>
+        </p:txBody>
+      </p:sp>
+      <p:sp>
+        <p:nvSpPr>
+          <p:cNvPr id="20" name="Text 18"/>
+          <p:cNvSpPr txBox="1"/>
+          <p:nvPr/>
+        </p:nvSpPr>
+        <p:spPr>
+          <a:xfrm>
+            <a:off x="7799832" y="6510528"/>
+            <a:ext cx="3840480" cy="237744"/>
+          </a:xfrm>
+          <a:prstGeom prst="rect">
+            <a:avLst/>
+          </a:prstGeom>
+          <a:noFill/>
+          <a:ln/>
+        </p:spPr>
+        <p:txBody>
+          <a:bodyPr wrap="square" lIns="0" tIns="0" rIns="0" bIns="0" rtlCol="0" anchor="ctr"/>
+          <a:lstStyle/>
+          <a:p>
             <a:pPr algn="r" indent="0" marL="0">
               <a:buNone/>
             </a:pPr>
             <a:r>
               <a:rPr lang="en-US" sz="800" dirty="0">
                 <a:solidFill>
-                  <a:srgbClr val="8C9299"/>
+                  <a:srgbClr val="7E95AF"/>
                 </a:solidFill>
                 <a:latin typeface="Arial" pitchFamily="34" charset="0"/>
                 <a:ea typeface="Arial" pitchFamily="34" charset="-122"/>
@@ -8541,7 +8917,7 @@
             <a:r>
               <a:rPr lang="en-US" sz="1050" b="1" spc="200" kern="0" dirty="0">
                 <a:solidFill>
-                  <a:srgbClr val="C67A43"/>
+                  <a:srgbClr val="00539B"/>
                 </a:solidFill>
                 <a:latin typeface="Arial" pitchFamily="34" charset="0"/>
                 <a:ea typeface="Arial" pitchFamily="34" charset="-122"/>
@@ -8570,7 +8946,7 @@
             </a:avLst>
           </a:prstGeom>
           <a:solidFill>
-            <a:srgbClr val="C67A43"/>
+            <a:srgbClr val="00539B"/>
           </a:solidFill>
           <a:ln/>
         </p:spPr>
@@ -8623,7 +8999,7 @@
             <a:r>
               <a:rPr lang="en-US" sz="2200" b="1" dirty="0">
                 <a:solidFill>
-                  <a:srgbClr val="1A1D21"/>
+                  <a:srgbClr val="0C2340"/>
                 </a:solidFill>
                 <a:latin typeface="Arial" pitchFamily="34" charset="0"/>
                 <a:ea typeface="Arial" pitchFamily="34" charset="-122"/>
@@ -8650,7 +9026,7 @@
             <a:avLst/>
           </a:prstGeom>
           <a:solidFill>
-            <a:srgbClr val="F5F4F2"/>
+            <a:srgbClr val="EFF3F7"/>
           </a:solidFill>
           <a:ln/>
         </p:spPr>
@@ -8682,7 +9058,7 @@
             <a:r>
               <a:rPr lang="en-US" sz="1050" b="1" spc="150" kern="0" dirty="0">
                 <a:solidFill>
-                  <a:srgbClr val="C67A43"/>
+                  <a:srgbClr val="00539B"/>
                 </a:solidFill>
                 <a:latin typeface="Arial" pitchFamily="34" charset="0"/>
                 <a:ea typeface="Arial" pitchFamily="34" charset="-122"/>
@@ -8721,7 +9097,7 @@
             <a:r>
               <a:rPr lang="en-US" sz="1200" dirty="0">
                 <a:solidFill>
-                  <a:srgbClr val="1A1D21"/>
+                  <a:srgbClr val="0C2340"/>
                 </a:solidFill>
                 <a:latin typeface="Arial" pitchFamily="34" charset="0"/>
                 <a:ea typeface="Arial" pitchFamily="34" charset="-122"/>
@@ -8748,7 +9124,7 @@
             <a:avLst/>
           </a:prstGeom>
           <a:solidFill>
-            <a:srgbClr val="F5F4F2"/>
+            <a:srgbClr val="EFF3F7"/>
           </a:solidFill>
           <a:ln/>
         </p:spPr>
@@ -8780,7 +9156,7 @@
             <a:r>
               <a:rPr lang="en-US" sz="1050" b="1" spc="150" kern="0" dirty="0">
                 <a:solidFill>
-                  <a:srgbClr val="C67A43"/>
+                  <a:srgbClr val="00539B"/>
                 </a:solidFill>
                 <a:latin typeface="Arial" pitchFamily="34" charset="0"/>
                 <a:ea typeface="Arial" pitchFamily="34" charset="-122"/>
@@ -8819,7 +9195,7 @@
             <a:r>
               <a:rPr lang="en-US" sz="1200" dirty="0">
                 <a:solidFill>
-                  <a:srgbClr val="1A1D21"/>
+                  <a:srgbClr val="0C2340"/>
                 </a:solidFill>
                 <a:latin typeface="Arial" pitchFamily="34" charset="0"/>
                 <a:ea typeface="Arial" pitchFamily="34" charset="-122"/>
@@ -8846,7 +9222,7 @@
             <a:avLst/>
           </a:prstGeom>
           <a:solidFill>
-            <a:srgbClr val="F5F4F2"/>
+            <a:srgbClr val="EFF3F7"/>
           </a:solidFill>
           <a:ln/>
         </p:spPr>
@@ -8878,7 +9254,7 @@
             <a:r>
               <a:rPr lang="en-US" sz="1050" b="1" spc="150" kern="0" dirty="0">
                 <a:solidFill>
-                  <a:srgbClr val="C67A43"/>
+                  <a:srgbClr val="00539B"/>
                 </a:solidFill>
                 <a:latin typeface="Arial" pitchFamily="34" charset="0"/>
                 <a:ea typeface="Arial" pitchFamily="34" charset="-122"/>
@@ -8917,7 +9293,7 @@
             <a:r>
               <a:rPr lang="en-US" sz="1200" dirty="0">
                 <a:solidFill>
-                  <a:srgbClr val="1A1D21"/>
+                  <a:srgbClr val="0C2340"/>
                 </a:solidFill>
                 <a:latin typeface="Arial" pitchFamily="34" charset="0"/>
                 <a:ea typeface="Arial" pitchFamily="34" charset="-122"/>
@@ -8956,7 +9332,7 @@
             <a:r>
               <a:rPr lang="en-US" sz="900" i="1" dirty="0">
                 <a:solidFill>
-                  <a:srgbClr val="6B7075"/>
+                  <a:srgbClr val="5B6B7C"/>
                 </a:solidFill>
                 <a:latin typeface="Arial" pitchFamily="34" charset="0"/>
                 <a:ea typeface="Arial" pitchFamily="34" charset="-122"/>
@@ -8995,7 +9371,7 @@
             <a:r>
               <a:rPr lang="en-US" sz="1000" b="1" spc="150" kern="0" dirty="0">
                 <a:solidFill>
-                  <a:srgbClr val="C67A43"/>
+                  <a:srgbClr val="00539B"/>
                 </a:solidFill>
                 <a:latin typeface="Arial" pitchFamily="34" charset="0"/>
                 <a:ea typeface="Arial" pitchFamily="34" charset="-122"/>
@@ -9022,11 +9398,11 @@
             <a:avLst/>
           </a:prstGeom>
           <a:solidFill>
-            <a:srgbClr val="F1EEEA"/>
+            <a:srgbClr val="EDF2F7"/>
           </a:solidFill>
           <a:ln w="9525">
             <a:solidFill>
-              <a:srgbClr val="C67A43"/>
+              <a:srgbClr val="00539B"/>
             </a:solidFill>
             <a:prstDash val="dash"/>
           </a:ln>
@@ -9059,7 +9435,7 @@
             <a:r>
               <a:rPr lang="en-US" sz="950" dirty="0">
                 <a:solidFill>
-                  <a:srgbClr val="6B7075"/>
+                  <a:srgbClr val="5B6B7C"/>
                 </a:solidFill>
                 <a:latin typeface="Arial" pitchFamily="34" charset="0"/>
                 <a:ea typeface="Arial" pitchFamily="34" charset="-122"/>
@@ -9076,7 +9452,7 @@
             <a:r>
               <a:rPr lang="en-US" sz="950" dirty="0">
                 <a:solidFill>
-                  <a:srgbClr val="6B7075"/>
+                  <a:srgbClr val="5B6B7C"/>
                 </a:solidFill>
                 <a:latin typeface="Arial" pitchFamily="34" charset="0"/>
                 <a:ea typeface="Arial" pitchFamily="34" charset="-122"/>
@@ -9103,7 +9479,7 @@
             <a:avLst/>
           </a:prstGeom>
           <a:solidFill>
-            <a:srgbClr val="C67A43"/>
+            <a:srgbClr val="00539B"/>
           </a:solidFill>
           <a:ln/>
         </p:spPr>
@@ -9135,7 +9511,7 @@
             <a:r>
               <a:rPr lang="en-US" sz="1000" dirty="0">
                 <a:solidFill>
-                  <a:srgbClr val="1A1D21"/>
+                  <a:srgbClr val="0C2340"/>
                 </a:solidFill>
                 <a:latin typeface="Arial" pitchFamily="34" charset="0"/>
                 <a:ea typeface="Arial" pitchFamily="34" charset="-122"/>
@@ -9162,7 +9538,7 @@
             <a:avLst/>
           </a:prstGeom>
           <a:solidFill>
-            <a:srgbClr val="C67A43"/>
+            <a:srgbClr val="00539B"/>
           </a:solidFill>
           <a:ln/>
         </p:spPr>
@@ -9194,7 +9570,7 @@
             <a:r>
               <a:rPr lang="en-US" sz="1000" dirty="0">
                 <a:solidFill>
-                  <a:srgbClr val="1A1D21"/>
+                  <a:srgbClr val="0C2340"/>
                 </a:solidFill>
                 <a:latin typeface="Arial" pitchFamily="34" charset="0"/>
                 <a:ea typeface="Arial" pitchFamily="34" charset="-122"/>
@@ -9221,7 +9597,7 @@
             <a:avLst/>
           </a:prstGeom>
           <a:solidFill>
-            <a:srgbClr val="C67A43"/>
+            <a:srgbClr val="00539B"/>
           </a:solidFill>
           <a:ln/>
         </p:spPr>
@@ -9253,7 +9629,7 @@
             <a:r>
               <a:rPr lang="en-US" sz="1000" dirty="0">
                 <a:solidFill>
-                  <a:srgbClr val="1A1D21"/>
+                  <a:srgbClr val="0C2340"/>
                 </a:solidFill>
                 <a:latin typeface="Arial" pitchFamily="34" charset="0"/>
                 <a:ea typeface="Arial" pitchFamily="34" charset="-122"/>
@@ -9292,7 +9668,7 @@
             <a:r>
               <a:rPr lang="en-US" sz="900" i="1" dirty="0">
                 <a:solidFill>
-                  <a:srgbClr val="6B7075"/>
+                  <a:srgbClr val="5B6B7C"/>
                 </a:solidFill>
                 <a:latin typeface="Arial" pitchFamily="34" charset="0"/>
                 <a:ea typeface="Arial" pitchFamily="34" charset="-122"/>
@@ -9313,7 +9689,7 @@
         <p:spPr>
           <a:xfrm>
             <a:off x="548640" y="6510528"/>
-            <a:ext cx="5029200" cy="237744"/>
+            <a:ext cx="3840480" cy="237744"/>
           </a:xfrm>
           <a:prstGeom prst="rect">
             <a:avLst/>
@@ -9331,7 +9707,7 @@
             <a:r>
               <a:rPr lang="en-US" sz="800" dirty="0">
                 <a:solidFill>
-                  <a:srgbClr val="9A9FA4"/>
+                  <a:srgbClr val="8B99A8"/>
                 </a:solidFill>
                 <a:latin typeface="Arial" pitchFamily="34" charset="0"/>
                 <a:ea typeface="Arial" pitchFamily="34" charset="-122"/>
@@ -9351,8 +9727,8 @@
         </p:nvSpPr>
         <p:spPr>
           <a:xfrm>
-            <a:off x="6583680" y="6510528"/>
-            <a:ext cx="5056632" cy="237744"/>
+            <a:off x="4480560" y="6510528"/>
+            <a:ext cx="3227832" cy="237744"/>
           </a:xfrm>
           <a:prstGeom prst="rect">
             <a:avLst/>
@@ -9364,13 +9740,52 @@
           <a:bodyPr wrap="square" lIns="0" tIns="0" rIns="0" bIns="0" rtlCol="0" anchor="ctr"/>
           <a:lstStyle/>
           <a:p>
+            <a:pPr algn="ctr" indent="0" marL="0">
+              <a:buNone/>
+            </a:pPr>
+            <a:r>
+              <a:rPr lang="en-US" sz="800" i="1" dirty="0">
+                <a:solidFill>
+                  <a:srgbClr val="00539B"/>
+                </a:solidFill>
+                <a:latin typeface="Arial" pitchFamily="34" charset="0"/>
+                <a:ea typeface="Arial" pitchFamily="34" charset="-122"/>
+                <a:cs typeface="Arial" pitchFamily="34" charset="-120"/>
+              </a:rPr>
+              <a:t>We deliver power… responsibly.®</a:t>
+            </a:r>
+            <a:endParaRPr lang="en-US" sz="800" dirty="0"/>
+          </a:p>
+        </p:txBody>
+      </p:sp>
+      <p:sp>
+        <p:nvSpPr>
+          <p:cNvPr id="27" name="Text 25"/>
+          <p:cNvSpPr txBox="1"/>
+          <p:nvPr/>
+        </p:nvSpPr>
+        <p:spPr>
+          <a:xfrm>
+            <a:off x="7799832" y="6510528"/>
+            <a:ext cx="3840480" cy="237744"/>
+          </a:xfrm>
+          <a:prstGeom prst="rect">
+            <a:avLst/>
+          </a:prstGeom>
+          <a:noFill/>
+          <a:ln/>
+        </p:spPr>
+        <p:txBody>
+          <a:bodyPr wrap="square" lIns="0" tIns="0" rIns="0" bIns="0" rtlCol="0" anchor="ctr"/>
+          <a:lstStyle/>
+          <a:p>
             <a:pPr algn="r" indent="0" marL="0">
               <a:buNone/>
             </a:pPr>
             <a:r>
               <a:rPr lang="en-US" sz="800" dirty="0">
                 <a:solidFill>
-                  <a:srgbClr val="9A9FA4"/>
+                  <a:srgbClr val="8B99A8"/>
                 </a:solidFill>
                 <a:latin typeface="Arial" pitchFamily="34" charset="0"/>
                 <a:ea typeface="Arial" pitchFamily="34" charset="-122"/>
@@ -9441,7 +9856,7 @@
             <a:r>
               <a:rPr lang="en-US" sz="1050" b="1" spc="200" kern="0" dirty="0">
                 <a:solidFill>
-                  <a:srgbClr val="C67A43"/>
+                  <a:srgbClr val="00539B"/>
                 </a:solidFill>
                 <a:latin typeface="Arial" pitchFamily="34" charset="0"/>
                 <a:ea typeface="Arial" pitchFamily="34" charset="-122"/>
@@ -9480,7 +9895,7 @@
             <a:r>
               <a:rPr lang="en-US" sz="3200" b="1" dirty="0">
                 <a:solidFill>
-                  <a:srgbClr val="1A1D21"/>
+                  <a:srgbClr val="0C2340"/>
                 </a:solidFill>
                 <a:latin typeface="Arial" pitchFamily="34" charset="0"/>
                 <a:ea typeface="Arial" pitchFamily="34" charset="-122"/>
@@ -9519,7 +9934,7 @@
             <a:r>
               <a:rPr lang="en-US" sz="2200" b="1" dirty="0">
                 <a:solidFill>
-                  <a:srgbClr val="C67A43"/>
+                  <a:srgbClr val="00539B"/>
                 </a:solidFill>
                 <a:latin typeface="Arial" pitchFamily="34" charset="0"/>
                 <a:ea typeface="Arial" pitchFamily="34" charset="-122"/>
@@ -9558,7 +9973,7 @@
             <a:r>
               <a:rPr lang="en-US" sz="1450" dirty="0">
                 <a:solidFill>
-                  <a:srgbClr val="1A1D21"/>
+                  <a:srgbClr val="0C2340"/>
                 </a:solidFill>
                 <a:latin typeface="Arial" pitchFamily="34" charset="0"/>
                 <a:ea typeface="Arial" pitchFamily="34" charset="-122"/>
@@ -9597,7 +10012,7 @@
             <a:r>
               <a:rPr lang="en-US" sz="1050" dirty="0">
                 <a:solidFill>
-                  <a:srgbClr val="6B7075"/>
+                  <a:srgbClr val="5B6B7C"/>
                 </a:solidFill>
                 <a:latin typeface="Arial" pitchFamily="34" charset="0"/>
                 <a:ea typeface="Arial" pitchFamily="34" charset="-122"/>
@@ -9636,7 +10051,7 @@
             <a:r>
               <a:rPr lang="en-US" sz="2200" b="1" dirty="0">
                 <a:solidFill>
-                  <a:srgbClr val="C67A43"/>
+                  <a:srgbClr val="00539B"/>
                 </a:solidFill>
                 <a:latin typeface="Arial" pitchFamily="34" charset="0"/>
                 <a:ea typeface="Arial" pitchFamily="34" charset="-122"/>
@@ -9675,7 +10090,7 @@
             <a:r>
               <a:rPr lang="en-US" sz="1450" dirty="0">
                 <a:solidFill>
-                  <a:srgbClr val="1A1D21"/>
+                  <a:srgbClr val="0C2340"/>
                 </a:solidFill>
                 <a:latin typeface="Arial" pitchFamily="34" charset="0"/>
                 <a:ea typeface="Arial" pitchFamily="34" charset="-122"/>
@@ -9714,7 +10129,7 @@
             <a:r>
               <a:rPr lang="en-US" sz="2200" b="1" dirty="0">
                 <a:solidFill>
-                  <a:srgbClr val="C67A43"/>
+                  <a:srgbClr val="00539B"/>
                 </a:solidFill>
                 <a:latin typeface="Arial" pitchFamily="34" charset="0"/>
                 <a:ea typeface="Arial" pitchFamily="34" charset="-122"/>
@@ -9753,7 +10168,7 @@
             <a:r>
               <a:rPr lang="en-US" sz="1450" dirty="0">
                 <a:solidFill>
-                  <a:srgbClr val="1A1D21"/>
+                  <a:srgbClr val="0C2340"/>
                 </a:solidFill>
                 <a:latin typeface="Arial" pitchFamily="34" charset="0"/>
                 <a:ea typeface="Arial" pitchFamily="34" charset="-122"/>
@@ -9780,7 +10195,7 @@
             <a:avLst/>
           </a:prstGeom>
           <a:solidFill>
-            <a:srgbClr val="F5F4F2"/>
+            <a:srgbClr val="EFF3F7"/>
           </a:solidFill>
           <a:ln/>
         </p:spPr>
@@ -9812,7 +10227,7 @@
             <a:r>
               <a:rPr lang="en-US" sz="1200" dirty="0">
                 <a:solidFill>
-                  <a:srgbClr val="1A1D21"/>
+                  <a:srgbClr val="0C2340"/>
                 </a:solidFill>
                 <a:latin typeface="Arial" pitchFamily="34" charset="0"/>
                 <a:ea typeface="Arial" pitchFamily="34" charset="-122"/>
@@ -9841,7 +10256,7 @@
             </a:avLst>
           </a:prstGeom>
           <a:solidFill>
-            <a:srgbClr val="C67A43"/>
+            <a:srgbClr val="00539B"/>
           </a:solidFill>
           <a:ln/>
         </p:spPr>
@@ -9894,7 +10309,7 @@
             <a:r>
               <a:rPr lang="en-US" sz="1200" dirty="0">
                 <a:solidFill>
-                  <a:srgbClr val="1A1D21"/>
+                  <a:srgbClr val="0C2340"/>
                 </a:solidFill>
                 <a:latin typeface="Arial" pitchFamily="34" charset="0"/>
                 <a:ea typeface="Arial" pitchFamily="34" charset="-122"/>
@@ -9915,7 +10330,7 @@
         <p:spPr>
           <a:xfrm>
             <a:off x="548640" y="6510528"/>
-            <a:ext cx="5029200" cy="237744"/>
+            <a:ext cx="3840480" cy="237744"/>
           </a:xfrm>
           <a:prstGeom prst="rect">
             <a:avLst/>
@@ -9933,7 +10348,7 @@
             <a:r>
               <a:rPr lang="en-US" sz="800" dirty="0">
                 <a:solidFill>
-                  <a:srgbClr val="9A9FA4"/>
+                  <a:srgbClr val="8B99A8"/>
                 </a:solidFill>
                 <a:latin typeface="Arial" pitchFamily="34" charset="0"/>
                 <a:ea typeface="Arial" pitchFamily="34" charset="-122"/>
@@ -9953,8 +10368,8 @@
         </p:nvSpPr>
         <p:spPr>
           <a:xfrm>
-            <a:off x="6583680" y="6510528"/>
-            <a:ext cx="5056632" cy="237744"/>
+            <a:off x="4480560" y="6510528"/>
+            <a:ext cx="3227832" cy="237744"/>
           </a:xfrm>
           <a:prstGeom prst="rect">
             <a:avLst/>
@@ -9966,13 +10381,52 @@
           <a:bodyPr wrap="square" lIns="0" tIns="0" rIns="0" bIns="0" rtlCol="0" anchor="ctr"/>
           <a:lstStyle/>
           <a:p>
+            <a:pPr algn="ctr" indent="0" marL="0">
+              <a:buNone/>
+            </a:pPr>
+            <a:r>
+              <a:rPr lang="en-US" sz="800" i="1" dirty="0">
+                <a:solidFill>
+                  <a:srgbClr val="00539B"/>
+                </a:solidFill>
+                <a:latin typeface="Arial" pitchFamily="34" charset="0"/>
+                <a:ea typeface="Arial" pitchFamily="34" charset="-122"/>
+                <a:cs typeface="Arial" pitchFamily="34" charset="-120"/>
+              </a:rPr>
+              <a:t>We deliver power… responsibly.®</a:t>
+            </a:r>
+            <a:endParaRPr lang="en-US" sz="800" dirty="0"/>
+          </a:p>
+        </p:txBody>
+      </p:sp>
+      <p:sp>
+        <p:nvSpPr>
+          <p:cNvPr id="17" name="Text 15"/>
+          <p:cNvSpPr txBox="1"/>
+          <p:nvPr/>
+        </p:nvSpPr>
+        <p:spPr>
+          <a:xfrm>
+            <a:off x="7799832" y="6510528"/>
+            <a:ext cx="3840480" cy="237744"/>
+          </a:xfrm>
+          <a:prstGeom prst="rect">
+            <a:avLst/>
+          </a:prstGeom>
+          <a:noFill/>
+          <a:ln/>
+        </p:spPr>
+        <p:txBody>
+          <a:bodyPr wrap="square" lIns="0" tIns="0" rIns="0" bIns="0" rtlCol="0" anchor="ctr"/>
+          <a:lstStyle/>
+          <a:p>
             <a:pPr algn="r" indent="0" marL="0">
               <a:buNone/>
             </a:pPr>
             <a:r>
               <a:rPr lang="en-US" sz="800" dirty="0">
                 <a:solidFill>
-                  <a:srgbClr val="9A9FA4"/>
+                  <a:srgbClr val="8B99A8"/>
                 </a:solidFill>
                 <a:latin typeface="Arial" pitchFamily="34" charset="0"/>
                 <a:ea typeface="Arial" pitchFamily="34" charset="-122"/>
@@ -10043,7 +10497,7 @@
             <a:r>
               <a:rPr lang="en-US" sz="1050" b="1" spc="200" kern="0" dirty="0">
                 <a:solidFill>
-                  <a:srgbClr val="C67A43"/>
+                  <a:srgbClr val="00539B"/>
                 </a:solidFill>
                 <a:latin typeface="Arial" pitchFamily="34" charset="0"/>
                 <a:ea typeface="Arial" pitchFamily="34" charset="-122"/>
@@ -10082,7 +10536,7 @@
             <a:r>
               <a:rPr lang="en-US" sz="2800" b="1" dirty="0">
                 <a:solidFill>
-                  <a:srgbClr val="1A1D21"/>
+                  <a:srgbClr val="0C2340"/>
                 </a:solidFill>
                 <a:latin typeface="Arial" pitchFamily="34" charset="0"/>
                 <a:ea typeface="Arial" pitchFamily="34" charset="-122"/>
@@ -10121,7 +10575,7 @@
             <a:r>
               <a:rPr lang="en-US" sz="1050" b="1" spc="150" kern="0" dirty="0">
                 <a:solidFill>
-                  <a:srgbClr val="C67A43"/>
+                  <a:srgbClr val="00539B"/>
                 </a:solidFill>
                 <a:latin typeface="Arial" pitchFamily="34" charset="0"/>
                 <a:ea typeface="Arial" pitchFamily="34" charset="-122"/>
@@ -10160,7 +10614,7 @@
             <a:r>
               <a:rPr lang="en-US" sz="1300" dirty="0">
                 <a:solidFill>
-                  <a:srgbClr val="1A1D21"/>
+                  <a:srgbClr val="0C2340"/>
                 </a:solidFill>
                 <a:latin typeface="Arial" pitchFamily="34" charset="0"/>
                 <a:ea typeface="Arial" pitchFamily="34" charset="-122"/>
@@ -10199,7 +10653,7 @@
             <a:r>
               <a:rPr lang="en-US" sz="1050" b="1" spc="150" kern="0" dirty="0">
                 <a:solidFill>
-                  <a:srgbClr val="C67A43"/>
+                  <a:srgbClr val="00539B"/>
                 </a:solidFill>
                 <a:latin typeface="Arial" pitchFamily="34" charset="0"/>
                 <a:ea typeface="Arial" pitchFamily="34" charset="-122"/>
@@ -10228,7 +10682,7 @@
             </a:avLst>
           </a:prstGeom>
           <a:solidFill>
-            <a:srgbClr val="C67A43"/>
+            <a:srgbClr val="00539B"/>
           </a:solidFill>
           <a:ln/>
         </p:spPr>
@@ -10281,7 +10735,7 @@
             <a:r>
               <a:rPr lang="en-US" sz="1300" dirty="0">
                 <a:solidFill>
-                  <a:srgbClr val="1A1D21"/>
+                  <a:srgbClr val="0C2340"/>
                 </a:solidFill>
                 <a:latin typeface="Arial" pitchFamily="34" charset="0"/>
                 <a:ea typeface="Arial" pitchFamily="34" charset="-122"/>
@@ -10320,7 +10774,7 @@
             <a:r>
               <a:rPr lang="en-US" sz="1050" b="1" spc="150" kern="0" dirty="0">
                 <a:solidFill>
-                  <a:srgbClr val="C67A43"/>
+                  <a:srgbClr val="00539B"/>
                 </a:solidFill>
                 <a:latin typeface="Arial" pitchFamily="34" charset="0"/>
                 <a:ea typeface="Arial" pitchFamily="34" charset="-122"/>
@@ -10359,7 +10813,7 @@
             <a:r>
               <a:rPr lang="en-US" sz="1300" dirty="0">
                 <a:solidFill>
-                  <a:srgbClr val="1A1D21"/>
+                  <a:srgbClr val="0C2340"/>
                 </a:solidFill>
                 <a:latin typeface="Arial" pitchFamily="34" charset="0"/>
                 <a:ea typeface="Arial" pitchFamily="34" charset="-122"/>
@@ -10398,7 +10852,7 @@
             <a:r>
               <a:rPr lang="en-US" sz="1200" i="1" dirty="0">
                 <a:solidFill>
-                  <a:srgbClr val="6B7075"/>
+                  <a:srgbClr val="5B6B7C"/>
                 </a:solidFill>
                 <a:latin typeface="Arial" pitchFamily="34" charset="0"/>
                 <a:ea typeface="Arial" pitchFamily="34" charset="-122"/>
@@ -10419,7 +10873,7 @@
         <p:spPr>
           <a:xfrm>
             <a:off x="548640" y="6510528"/>
-            <a:ext cx="5029200" cy="237744"/>
+            <a:ext cx="3840480" cy="237744"/>
           </a:xfrm>
           <a:prstGeom prst="rect">
             <a:avLst/>
@@ -10437,7 +10891,7 @@
             <a:r>
               <a:rPr lang="en-US" sz="800" dirty="0">
                 <a:solidFill>
-                  <a:srgbClr val="9A9FA4"/>
+                  <a:srgbClr val="8B99A8"/>
                 </a:solidFill>
                 <a:latin typeface="Arial" pitchFamily="34" charset="0"/>
                 <a:ea typeface="Arial" pitchFamily="34" charset="-122"/>
@@ -10457,8 +10911,8 @@
         </p:nvSpPr>
         <p:spPr>
           <a:xfrm>
-            <a:off x="6583680" y="6510528"/>
-            <a:ext cx="5056632" cy="237744"/>
+            <a:off x="4480560" y="6510528"/>
+            <a:ext cx="3227832" cy="237744"/>
           </a:xfrm>
           <a:prstGeom prst="rect">
             <a:avLst/>
@@ -10470,13 +10924,52 @@
           <a:bodyPr wrap="square" lIns="0" tIns="0" rIns="0" bIns="0" rtlCol="0" anchor="ctr"/>
           <a:lstStyle/>
           <a:p>
+            <a:pPr algn="ctr" indent="0" marL="0">
+              <a:buNone/>
+            </a:pPr>
+            <a:r>
+              <a:rPr lang="en-US" sz="800" i="1" dirty="0">
+                <a:solidFill>
+                  <a:srgbClr val="00539B"/>
+                </a:solidFill>
+                <a:latin typeface="Arial" pitchFamily="34" charset="0"/>
+                <a:ea typeface="Arial" pitchFamily="34" charset="-122"/>
+                <a:cs typeface="Arial" pitchFamily="34" charset="-120"/>
+              </a:rPr>
+              <a:t>We deliver power… responsibly.®</a:t>
+            </a:r>
+            <a:endParaRPr lang="en-US" sz="800" dirty="0"/>
+          </a:p>
+        </p:txBody>
+      </p:sp>
+      <p:sp>
+        <p:nvSpPr>
+          <p:cNvPr id="14" name="Text 12"/>
+          <p:cNvSpPr txBox="1"/>
+          <p:nvPr/>
+        </p:nvSpPr>
+        <p:spPr>
+          <a:xfrm>
+            <a:off x="7799832" y="6510528"/>
+            <a:ext cx="3840480" cy="237744"/>
+          </a:xfrm>
+          <a:prstGeom prst="rect">
+            <a:avLst/>
+          </a:prstGeom>
+          <a:noFill/>
+          <a:ln/>
+        </p:spPr>
+        <p:txBody>
+          <a:bodyPr wrap="square" lIns="0" tIns="0" rIns="0" bIns="0" rtlCol="0" anchor="ctr"/>
+          <a:lstStyle/>
+          <a:p>
             <a:pPr algn="r" indent="0" marL="0">
               <a:buNone/>
             </a:pPr>
             <a:r>
               <a:rPr lang="en-US" sz="800" dirty="0">
                 <a:solidFill>
-                  <a:srgbClr val="9A9FA4"/>
+                  <a:srgbClr val="8B99A8"/>
                 </a:solidFill>
                 <a:latin typeface="Arial" pitchFamily="34" charset="0"/>
                 <a:ea typeface="Arial" pitchFamily="34" charset="-122"/>
@@ -10547,7 +11040,7 @@
             <a:r>
               <a:rPr lang="en-US" sz="1050" b="1" spc="200" kern="0" dirty="0">
                 <a:solidFill>
-                  <a:srgbClr val="C67A43"/>
+                  <a:srgbClr val="00539B"/>
                 </a:solidFill>
                 <a:latin typeface="Arial" pitchFamily="34" charset="0"/>
                 <a:ea typeface="Arial" pitchFamily="34" charset="-122"/>
@@ -10586,7 +11079,7 @@
             <a:r>
               <a:rPr lang="en-US" sz="9200" b="1" dirty="0">
                 <a:solidFill>
-                  <a:srgbClr val="C67A43"/>
+                  <a:srgbClr val="00539B"/>
                 </a:solidFill>
                 <a:latin typeface="Arial" pitchFamily="34" charset="0"/>
                 <a:ea typeface="Arial" pitchFamily="34" charset="-122"/>
@@ -10625,7 +11118,7 @@
             <a:r>
               <a:rPr lang="en-US" sz="1700" dirty="0">
                 <a:solidFill>
-                  <a:srgbClr val="1A1D21"/>
+                  <a:srgbClr val="0C2340"/>
                 </a:solidFill>
                 <a:latin typeface="Arial" pitchFamily="34" charset="0"/>
                 <a:ea typeface="Arial" pitchFamily="34" charset="-122"/>
@@ -10652,7 +11145,7 @@
             <a:avLst/>
           </a:prstGeom>
           <a:solidFill>
-            <a:srgbClr val="C67A43"/>
+            <a:srgbClr val="00539B"/>
           </a:solidFill>
           <a:ln/>
         </p:spPr>
@@ -10684,7 +11177,7 @@
             <a:r>
               <a:rPr lang="en-US" sz="1250" dirty="0">
                 <a:solidFill>
-                  <a:srgbClr val="1A1D21"/>
+                  <a:srgbClr val="0C2340"/>
                 </a:solidFill>
                 <a:latin typeface="Arial" pitchFamily="34" charset="0"/>
                 <a:ea typeface="Arial" pitchFamily="34" charset="-122"/>
@@ -10711,7 +11204,7 @@
             <a:avLst/>
           </a:prstGeom>
           <a:solidFill>
-            <a:srgbClr val="C67A43"/>
+            <a:srgbClr val="00539B"/>
           </a:solidFill>
           <a:ln/>
         </p:spPr>
@@ -10743,7 +11236,7 @@
             <a:r>
               <a:rPr lang="en-US" sz="1250" dirty="0">
                 <a:solidFill>
-                  <a:srgbClr val="1A1D21"/>
+                  <a:srgbClr val="0C2340"/>
                 </a:solidFill>
                 <a:latin typeface="Arial" pitchFamily="34" charset="0"/>
                 <a:ea typeface="Arial" pitchFamily="34" charset="-122"/>
@@ -10770,7 +11263,7 @@
             <a:avLst/>
           </a:prstGeom>
           <a:solidFill>
-            <a:srgbClr val="C67A43"/>
+            <a:srgbClr val="00539B"/>
           </a:solidFill>
           <a:ln/>
         </p:spPr>
@@ -10802,7 +11295,7 @@
             <a:r>
               <a:rPr lang="en-US" sz="1250" dirty="0">
                 <a:solidFill>
-                  <a:srgbClr val="1A1D21"/>
+                  <a:srgbClr val="0C2340"/>
                 </a:solidFill>
                 <a:latin typeface="Arial" pitchFamily="34" charset="0"/>
                 <a:ea typeface="Arial" pitchFamily="34" charset="-122"/>
@@ -10841,7 +11334,7 @@
             <a:r>
               <a:rPr lang="en-US" sz="1200" i="1" dirty="0">
                 <a:solidFill>
-                  <a:srgbClr val="6B7075"/>
+                  <a:srgbClr val="5B6B7C"/>
                 </a:solidFill>
                 <a:latin typeface="Arial" pitchFamily="34" charset="0"/>
                 <a:ea typeface="Arial" pitchFamily="34" charset="-122"/>
@@ -10862,7 +11355,7 @@
         <p:spPr>
           <a:xfrm>
             <a:off x="548640" y="6510528"/>
-            <a:ext cx="5029200" cy="237744"/>
+            <a:ext cx="3840480" cy="237744"/>
           </a:xfrm>
           <a:prstGeom prst="rect">
             <a:avLst/>
@@ -10880,7 +11373,7 @@
             <a:r>
               <a:rPr lang="en-US" sz="800" dirty="0">
                 <a:solidFill>
-                  <a:srgbClr val="9A9FA4"/>
+                  <a:srgbClr val="8B99A8"/>
                 </a:solidFill>
                 <a:latin typeface="Arial" pitchFamily="34" charset="0"/>
                 <a:ea typeface="Arial" pitchFamily="34" charset="-122"/>
@@ -10900,8 +11393,8 @@
         </p:nvSpPr>
         <p:spPr>
           <a:xfrm>
-            <a:off x="6583680" y="6510528"/>
-            <a:ext cx="5056632" cy="237744"/>
+            <a:off x="4480560" y="6510528"/>
+            <a:ext cx="3227832" cy="237744"/>
           </a:xfrm>
           <a:prstGeom prst="rect">
             <a:avLst/>
@@ -10913,13 +11406,52 @@
           <a:bodyPr wrap="square" lIns="0" tIns="0" rIns="0" bIns="0" rtlCol="0" anchor="ctr"/>
           <a:lstStyle/>
           <a:p>
+            <a:pPr algn="ctr" indent="0" marL="0">
+              <a:buNone/>
+            </a:pPr>
+            <a:r>
+              <a:rPr lang="en-US" sz="800" i="1" dirty="0">
+                <a:solidFill>
+                  <a:srgbClr val="00539B"/>
+                </a:solidFill>
+                <a:latin typeface="Arial" pitchFamily="34" charset="0"/>
+                <a:ea typeface="Arial" pitchFamily="34" charset="-122"/>
+                <a:cs typeface="Arial" pitchFamily="34" charset="-120"/>
+              </a:rPr>
+              <a:t>We deliver power… responsibly.®</a:t>
+            </a:r>
+            <a:endParaRPr lang="en-US" sz="800" dirty="0"/>
+          </a:p>
+        </p:txBody>
+      </p:sp>
+      <p:sp>
+        <p:nvSpPr>
+          <p:cNvPr id="14" name="Text 12"/>
+          <p:cNvSpPr txBox="1"/>
+          <p:nvPr/>
+        </p:nvSpPr>
+        <p:spPr>
+          <a:xfrm>
+            <a:off x="7799832" y="6510528"/>
+            <a:ext cx="3840480" cy="237744"/>
+          </a:xfrm>
+          <a:prstGeom prst="rect">
+            <a:avLst/>
+          </a:prstGeom>
+          <a:noFill/>
+          <a:ln/>
+        </p:spPr>
+        <p:txBody>
+          <a:bodyPr wrap="square" lIns="0" tIns="0" rIns="0" bIns="0" rtlCol="0" anchor="ctr"/>
+          <a:lstStyle/>
+          <a:p>
             <a:pPr algn="r" indent="0" marL="0">
               <a:buNone/>
             </a:pPr>
             <a:r>
               <a:rPr lang="en-US" sz="800" dirty="0">
                 <a:solidFill>
-                  <a:srgbClr val="9A9FA4"/>
+                  <a:srgbClr val="8B99A8"/>
                 </a:solidFill>
                 <a:latin typeface="Arial" pitchFamily="34" charset="0"/>
                 <a:ea typeface="Arial" pitchFamily="34" charset="-122"/>
@@ -10945,7 +11477,7 @@
     <p:bg>
       <p:bgPr>
         <a:solidFill>
-          <a:srgbClr val="1A1D21"/>
+          <a:srgbClr val="0C2340"/>
         </a:solidFill>
       </p:bgPr>
     </p:bg>
@@ -10990,7 +11522,7 @@
             <a:r>
               <a:rPr lang="en-US" sz="1050" b="1" spc="200" kern="0" dirty="0">
                 <a:solidFill>
-                  <a:srgbClr val="C67A43"/>
+                  <a:srgbClr val="6FA8DC"/>
                 </a:solidFill>
                 <a:latin typeface="Arial" pitchFamily="34" charset="0"/>
                 <a:ea typeface="Arial" pitchFamily="34" charset="-122"/>
@@ -11004,120 +11536,24 @@
       </p:sp>
       <p:sp>
         <p:nvSpPr>
-          <p:cNvPr id="3" name="Text 1"/>
-          <p:cNvSpPr txBox="1"/>
-          <p:nvPr/>
-        </p:nvSpPr>
-        <p:spPr>
-          <a:xfrm>
-            <a:off x="548640" y="768096"/>
-            <a:ext cx="11091672" cy="777240"/>
-          </a:xfrm>
-          <a:prstGeom prst="rect">
-            <a:avLst/>
-          </a:prstGeom>
-          <a:noFill/>
-          <a:ln/>
-        </p:spPr>
-        <p:txBody>
-          <a:bodyPr wrap="square" lIns="0" tIns="0" rIns="0" bIns="0" rtlCol="0" anchor="t"/>
-          <a:lstStyle/>
-          <a:p>
-            <a:pPr algn="l" indent="0" marL="0">
-              <a:buNone/>
-            </a:pPr>
-            <a:r>
-              <a:rPr lang="en-US" sz="3200" b="1" dirty="0">
-                <a:solidFill>
-                  <a:srgbClr val="FFFFFF"/>
-                </a:solidFill>
-                <a:latin typeface="Arial" pitchFamily="34" charset="0"/>
-                <a:ea typeface="Arial" pitchFamily="34" charset="-122"/>
-                <a:cs typeface="Arial" pitchFamily="34" charset="-120"/>
-              </a:rPr>
-              <a:t>Names on the page. Ask per lane.</a:t>
-            </a:r>
-            <a:endParaRPr lang="en-US" sz="3200" dirty="0"/>
-          </a:p>
-        </p:txBody>
-      </p:sp>
-      <p:sp>
-        <p:nvSpPr>
-          <p:cNvPr id="4" name="Shape 2"/>
+          <p:cNvPr id="3" name="Shape 1"/>
           <p:cNvSpPr/>
           <p:nvPr/>
         </p:nvSpPr>
         <p:spPr>
           <a:xfrm>
-            <a:off x="548640" y="1783080"/>
-            <a:ext cx="5394960" cy="502920"/>
-          </a:xfrm>
-          <a:prstGeom prst="rect">
-            <a:avLst/>
-          </a:prstGeom>
-          <a:solidFill>
-            <a:srgbClr val="C67A43"/>
-          </a:solidFill>
-          <a:ln/>
-        </p:spPr>
-      </p:sp>
-      <p:sp>
-        <p:nvSpPr>
-          <p:cNvPr id="5" name="Text 3"/>
-          <p:cNvSpPr txBox="1"/>
-          <p:nvPr/>
-        </p:nvSpPr>
-        <p:spPr>
-          <a:xfrm>
-            <a:off x="548640" y="1783080"/>
-            <a:ext cx="5394960" cy="502920"/>
-          </a:xfrm>
-          <a:prstGeom prst="rect">
-            <a:avLst/>
-          </a:prstGeom>
-          <a:noFill/>
-          <a:ln/>
-        </p:spPr>
-        <p:txBody>
-          <a:bodyPr wrap="square" lIns="0" tIns="0" rIns="0" bIns="0" rtlCol="0" anchor="ctr"/>
-          <a:lstStyle/>
-          <a:p>
-            <a:pPr algn="ctr" indent="0" marL="0">
-              <a:buNone/>
-            </a:pPr>
-            <a:r>
-              <a:rPr lang="en-US" sz="1150" b="1" dirty="0">
-                <a:solidFill>
-                  <a:srgbClr val="FFFFFF"/>
-                </a:solidFill>
-                <a:latin typeface="Arial" pitchFamily="34" charset="0"/>
-                <a:ea typeface="Arial" pitchFamily="34" charset="-122"/>
-                <a:cs typeface="Arial" pitchFamily="34" charset="-120"/>
-              </a:rPr>
-              <a:t>Stephan Hardt · Marc — vertical leads</a:t>
-            </a:r>
-            <a:endParaRPr lang="en-US" sz="1150" dirty="0"/>
-          </a:p>
-        </p:txBody>
-      </p:sp>
-      <p:sp>
-        <p:nvSpPr>
-          <p:cNvPr id="6" name="Shape 4"/>
-          <p:cNvSpPr/>
-          <p:nvPr/>
-        </p:nvSpPr>
-        <p:spPr>
-          <a:xfrm>
-            <a:off x="3246120" y="2286000"/>
-            <a:ext cx="0" cy="228600"/>
-          </a:xfrm>
-          <a:prstGeom prst="line">
-            <a:avLst/>
-          </a:prstGeom>
-          <a:noFill/>
-          <a:ln w="12700">
+            <a:off x="10607040" y="237744"/>
+            <a:ext cx="384048" cy="274320"/>
+          </a:xfrm>
+          <a:prstGeom prst="arc">
+            <a:avLst>
+              <a:gd name="adj1" fmla="val 12000000"/>
+              <a:gd name="adj2" fmla="val 19800000"/>
+            </a:avLst>
+          </a:prstGeom>
+          <a:ln w="28575">
             <a:solidFill>
-              <a:srgbClr val="A6ACB3"/>
+              <a:srgbClr val="E4322B"/>
             </a:solidFill>
             <a:prstDash val="solid"/>
           </a:ln>
@@ -11125,7 +11561,167 @@
       </p:sp>
       <p:sp>
         <p:nvSpPr>
-          <p:cNvPr id="7" name="Shape 5"/>
+          <p:cNvPr id="4" name="Text 2"/>
+          <p:cNvSpPr txBox="1"/>
+          <p:nvPr/>
+        </p:nvSpPr>
+        <p:spPr>
+          <a:xfrm>
+            <a:off x="10104120" y="420624"/>
+            <a:ext cx="1554480" cy="310896"/>
+          </a:xfrm>
+          <a:prstGeom prst="rect">
+            <a:avLst/>
+          </a:prstGeom>
+          <a:noFill/>
+          <a:ln/>
+        </p:spPr>
+        <p:txBody>
+          <a:bodyPr wrap="square" lIns="0" tIns="0" rIns="0" bIns="0" rtlCol="0" anchor="ctr"/>
+          <a:lstStyle/>
+          <a:p>
+            <a:pPr algn="r" indent="0" marL="0">
+              <a:buNone/>
+            </a:pPr>
+            <a:r>
+              <a:rPr lang="en-US" sz="1400" b="1" dirty="0">
+                <a:solidFill>
+                  <a:srgbClr val="FFFFFF"/>
+                </a:solidFill>
+                <a:latin typeface="Arial" pitchFamily="34" charset="0"/>
+                <a:ea typeface="Arial" pitchFamily="34" charset="-122"/>
+                <a:cs typeface="Arial" pitchFamily="34" charset="-120"/>
+              </a:rPr>
+              <a:t>Southwire®</a:t>
+            </a:r>
+            <a:endParaRPr lang="en-US" sz="1400" dirty="0"/>
+          </a:p>
+        </p:txBody>
+      </p:sp>
+      <p:sp>
+        <p:nvSpPr>
+          <p:cNvPr id="5" name="Text 3"/>
+          <p:cNvSpPr txBox="1"/>
+          <p:nvPr/>
+        </p:nvSpPr>
+        <p:spPr>
+          <a:xfrm>
+            <a:off x="548640" y="768096"/>
+            <a:ext cx="11091672" cy="777240"/>
+          </a:xfrm>
+          <a:prstGeom prst="rect">
+            <a:avLst/>
+          </a:prstGeom>
+          <a:noFill/>
+          <a:ln/>
+        </p:spPr>
+        <p:txBody>
+          <a:bodyPr wrap="square" lIns="0" tIns="0" rIns="0" bIns="0" rtlCol="0" anchor="t"/>
+          <a:lstStyle/>
+          <a:p>
+            <a:pPr algn="l" indent="0" marL="0">
+              <a:buNone/>
+            </a:pPr>
+            <a:r>
+              <a:rPr lang="en-US" sz="3200" b="1" dirty="0">
+                <a:solidFill>
+                  <a:srgbClr val="FFFFFF"/>
+                </a:solidFill>
+                <a:latin typeface="Arial" pitchFamily="34" charset="0"/>
+                <a:ea typeface="Arial" pitchFamily="34" charset="-122"/>
+                <a:cs typeface="Arial" pitchFamily="34" charset="-120"/>
+              </a:rPr>
+              <a:t>Names on the page. Ask per lane.</a:t>
+            </a:r>
+            <a:endParaRPr lang="en-US" sz="3200" dirty="0"/>
+          </a:p>
+        </p:txBody>
+      </p:sp>
+      <p:sp>
+        <p:nvSpPr>
+          <p:cNvPr id="6" name="Shape 4"/>
+          <p:cNvSpPr/>
+          <p:nvPr/>
+        </p:nvSpPr>
+        <p:spPr>
+          <a:xfrm>
+            <a:off x="548640" y="1783080"/>
+            <a:ext cx="5394960" cy="502920"/>
+          </a:xfrm>
+          <a:prstGeom prst="rect">
+            <a:avLst/>
+          </a:prstGeom>
+          <a:solidFill>
+            <a:srgbClr val="00539B"/>
+          </a:solidFill>
+          <a:ln/>
+        </p:spPr>
+      </p:sp>
+      <p:sp>
+        <p:nvSpPr>
+          <p:cNvPr id="7" name="Text 5"/>
+          <p:cNvSpPr txBox="1"/>
+          <p:nvPr/>
+        </p:nvSpPr>
+        <p:spPr>
+          <a:xfrm>
+            <a:off x="548640" y="1783080"/>
+            <a:ext cx="5394960" cy="502920"/>
+          </a:xfrm>
+          <a:prstGeom prst="rect">
+            <a:avLst/>
+          </a:prstGeom>
+          <a:noFill/>
+          <a:ln/>
+        </p:spPr>
+        <p:txBody>
+          <a:bodyPr wrap="square" lIns="0" tIns="0" rIns="0" bIns="0" rtlCol="0" anchor="ctr"/>
+          <a:lstStyle/>
+          <a:p>
+            <a:pPr algn="ctr" indent="0" marL="0">
+              <a:buNone/>
+            </a:pPr>
+            <a:r>
+              <a:rPr lang="en-US" sz="1150" b="1" dirty="0">
+                <a:solidFill>
+                  <a:srgbClr val="FFFFFF"/>
+                </a:solidFill>
+                <a:latin typeface="Arial" pitchFamily="34" charset="0"/>
+                <a:ea typeface="Arial" pitchFamily="34" charset="-122"/>
+                <a:cs typeface="Arial" pitchFamily="34" charset="-120"/>
+              </a:rPr>
+              <a:t>Stephan Hardt · Marc — vertical leads</a:t>
+            </a:r>
+            <a:endParaRPr lang="en-US" sz="1150" dirty="0"/>
+          </a:p>
+        </p:txBody>
+      </p:sp>
+      <p:sp>
+        <p:nvSpPr>
+          <p:cNvPr id="8" name="Shape 6"/>
+          <p:cNvSpPr/>
+          <p:nvPr/>
+        </p:nvSpPr>
+        <p:spPr>
+          <a:xfrm>
+            <a:off x="3246120" y="2286000"/>
+            <a:ext cx="0" cy="228600"/>
+          </a:xfrm>
+          <a:prstGeom prst="line">
+            <a:avLst/>
+          </a:prstGeom>
+          <a:noFill/>
+          <a:ln w="12700">
+            <a:solidFill>
+              <a:srgbClr val="9FB4CC"/>
+            </a:solidFill>
+            <a:prstDash val="solid"/>
+          </a:ln>
+        </p:spPr>
+      </p:sp>
+      <p:sp>
+        <p:nvSpPr>
+          <p:cNvPr id="9" name="Shape 7"/>
           <p:cNvSpPr/>
           <p:nvPr/>
         </p:nvSpPr>
@@ -11138,14 +11734,14 @@
             <a:avLst/>
           </a:prstGeom>
           <a:solidFill>
-            <a:srgbClr val="23272C"/>
+            <a:srgbClr val="16395E"/>
           </a:solidFill>
           <a:ln/>
         </p:spPr>
       </p:sp>
       <p:sp>
         <p:nvSpPr>
-          <p:cNvPr id="8" name="Text 6"/>
+          <p:cNvPr id="10" name="Text 8"/>
           <p:cNvSpPr txBox="1"/>
           <p:nvPr/>
         </p:nvSpPr>
@@ -11187,7 +11783,7 @@
             <a:r>
               <a:rPr lang="en-US" sz="900" dirty="0">
                 <a:solidFill>
-                  <a:srgbClr val="A6ACB3"/>
+                  <a:srgbClr val="9FB4CC"/>
                 </a:solidFill>
                 <a:latin typeface="Arial" pitchFamily="34" charset="0"/>
                 <a:ea typeface="Arial" pitchFamily="34" charset="-122"/>
@@ -11201,7 +11797,7 @@
       </p:sp>
       <p:sp>
         <p:nvSpPr>
-          <p:cNvPr id="9" name="Shape 7"/>
+          <p:cNvPr id="11" name="Shape 9"/>
           <p:cNvSpPr/>
           <p:nvPr/>
         </p:nvSpPr>
@@ -11214,14 +11810,14 @@
             <a:avLst/>
           </a:prstGeom>
           <a:solidFill>
-            <a:srgbClr val="23272C"/>
+            <a:srgbClr val="16395E"/>
           </a:solidFill>
           <a:ln/>
         </p:spPr>
       </p:sp>
       <p:sp>
         <p:nvSpPr>
-          <p:cNvPr id="10" name="Text 8"/>
+          <p:cNvPr id="12" name="Text 10"/>
           <p:cNvSpPr txBox="1"/>
           <p:nvPr/>
         </p:nvSpPr>
@@ -11263,7 +11859,7 @@
             <a:r>
               <a:rPr lang="en-US" sz="900" dirty="0">
                 <a:solidFill>
-                  <a:srgbClr val="A6ACB3"/>
+                  <a:srgbClr val="9FB4CC"/>
                 </a:solidFill>
                 <a:latin typeface="Arial" pitchFamily="34" charset="0"/>
                 <a:ea typeface="Arial" pitchFamily="34" charset="-122"/>
@@ -11277,7 +11873,7 @@
       </p:sp>
       <p:sp>
         <p:nvSpPr>
-          <p:cNvPr id="11" name="Shape 9"/>
+          <p:cNvPr id="13" name="Shape 11"/>
           <p:cNvSpPr/>
           <p:nvPr/>
         </p:nvSpPr>
@@ -11290,14 +11886,14 @@
             <a:avLst/>
           </a:prstGeom>
           <a:solidFill>
-            <a:srgbClr val="23272C"/>
+            <a:srgbClr val="16395E"/>
           </a:solidFill>
           <a:ln/>
         </p:spPr>
       </p:sp>
       <p:sp>
         <p:nvSpPr>
-          <p:cNvPr id="12" name="Text 10"/>
+          <p:cNvPr id="14" name="Text 12"/>
           <p:cNvSpPr txBox="1"/>
           <p:nvPr/>
         </p:nvSpPr>
@@ -11339,7 +11935,7 @@
             <a:r>
               <a:rPr lang="en-US" sz="900" dirty="0">
                 <a:solidFill>
-                  <a:srgbClr val="A6ACB3"/>
+                  <a:srgbClr val="9FB4CC"/>
                 </a:solidFill>
                 <a:latin typeface="Arial" pitchFamily="34" charset="0"/>
                 <a:ea typeface="Arial" pitchFamily="34" charset="-122"/>
@@ -11353,7 +11949,7 @@
       </p:sp>
       <p:sp>
         <p:nvSpPr>
-          <p:cNvPr id="13" name="Shape 11"/>
+          <p:cNvPr id="15" name="Shape 13"/>
           <p:cNvSpPr/>
           <p:nvPr/>
         </p:nvSpPr>
@@ -11366,14 +11962,14 @@
             <a:avLst/>
           </a:prstGeom>
           <a:solidFill>
-            <a:srgbClr val="23272C"/>
+            <a:srgbClr val="16395E"/>
           </a:solidFill>
           <a:ln/>
         </p:spPr>
       </p:sp>
       <p:sp>
         <p:nvSpPr>
-          <p:cNvPr id="14" name="Text 12"/>
+          <p:cNvPr id="16" name="Text 14"/>
           <p:cNvSpPr txBox="1"/>
           <p:nvPr/>
         </p:nvSpPr>
@@ -11415,7 +12011,7 @@
             <a:r>
               <a:rPr lang="en-US" sz="900" dirty="0">
                 <a:solidFill>
-                  <a:srgbClr val="A6ACB3"/>
+                  <a:srgbClr val="9FB4CC"/>
                 </a:solidFill>
                 <a:latin typeface="Arial" pitchFamily="34" charset="0"/>
                 <a:ea typeface="Arial" pitchFamily="34" charset="-122"/>
@@ -11429,7 +12025,7 @@
       </p:sp>
       <p:sp>
         <p:nvSpPr>
-          <p:cNvPr id="15" name="Shape 13"/>
+          <p:cNvPr id="17" name="Shape 15"/>
           <p:cNvSpPr/>
           <p:nvPr/>
         </p:nvSpPr>
@@ -11442,14 +12038,14 @@
             <a:avLst/>
           </a:prstGeom>
           <a:solidFill>
-            <a:srgbClr val="23272C"/>
+            <a:srgbClr val="16395E"/>
           </a:solidFill>
           <a:ln/>
         </p:spPr>
       </p:sp>
       <p:sp>
         <p:nvSpPr>
-          <p:cNvPr id="16" name="Text 14"/>
+          <p:cNvPr id="18" name="Text 16"/>
           <p:cNvSpPr txBox="1"/>
           <p:nvPr/>
         </p:nvSpPr>
@@ -11491,7 +12087,7 @@
             <a:r>
               <a:rPr lang="en-US" sz="900" dirty="0">
                 <a:solidFill>
-                  <a:srgbClr val="A6ACB3"/>
+                  <a:srgbClr val="9FB4CC"/>
                 </a:solidFill>
                 <a:latin typeface="Arial" pitchFamily="34" charset="0"/>
                 <a:ea typeface="Arial" pitchFamily="34" charset="-122"/>
@@ -11505,7 +12101,7 @@
       </p:sp>
       <p:sp>
         <p:nvSpPr>
-          <p:cNvPr id="17" name="Shape 15"/>
+          <p:cNvPr id="19" name="Shape 17"/>
           <p:cNvSpPr/>
           <p:nvPr/>
         </p:nvSpPr>
@@ -11518,14 +12114,14 @@
             <a:avLst/>
           </a:prstGeom>
           <a:solidFill>
-            <a:srgbClr val="23272C"/>
+            <a:srgbClr val="16395E"/>
           </a:solidFill>
           <a:ln/>
         </p:spPr>
       </p:sp>
       <p:sp>
         <p:nvSpPr>
-          <p:cNvPr id="18" name="Text 16"/>
+          <p:cNvPr id="20" name="Text 18"/>
           <p:cNvSpPr txBox="1"/>
           <p:nvPr/>
         </p:nvSpPr>
@@ -11567,7 +12163,7 @@
             <a:r>
               <a:rPr lang="en-US" sz="900" dirty="0">
                 <a:solidFill>
-                  <a:srgbClr val="A6ACB3"/>
+                  <a:srgbClr val="9FB4CC"/>
                 </a:solidFill>
                 <a:latin typeface="Arial" pitchFamily="34" charset="0"/>
                 <a:ea typeface="Arial" pitchFamily="34" charset="-122"/>
@@ -11581,7 +12177,7 @@
       </p:sp>
       <p:sp>
         <p:nvSpPr>
-          <p:cNvPr id="19" name="Text 17"/>
+          <p:cNvPr id="21" name="Text 19"/>
           <p:cNvSpPr txBox="1"/>
           <p:nvPr/>
         </p:nvSpPr>
@@ -11606,7 +12202,7 @@
             <a:r>
               <a:rPr lang="en-US" sz="1000" b="1" spc="150" kern="0" dirty="0">
                 <a:solidFill>
-                  <a:srgbClr val="C67A43"/>
+                  <a:srgbClr val="6FA8DC"/>
                 </a:solidFill>
                 <a:latin typeface="Arial" pitchFamily="34" charset="0"/>
                 <a:ea typeface="Arial" pitchFamily="34" charset="-122"/>
@@ -11620,7 +12216,7 @@
       </p:sp>
       <p:sp>
         <p:nvSpPr>
-          <p:cNvPr id="20" name="Text 18"/>
+          <p:cNvPr id="22" name="Text 20"/>
           <p:cNvSpPr txBox="1"/>
           <p:nvPr/>
         </p:nvSpPr>
@@ -11645,7 +12241,7 @@
             <a:r>
               <a:rPr lang="en-US" sz="1000" b="1" spc="100" kern="0" dirty="0">
                 <a:solidFill>
-                  <a:srgbClr val="C67A43"/>
+                  <a:srgbClr val="6FA8DC"/>
                 </a:solidFill>
                 <a:latin typeface="Arial" pitchFamily="34" charset="0"/>
                 <a:ea typeface="Arial" pitchFamily="34" charset="-122"/>
@@ -11659,7 +12255,7 @@
       </p:sp>
       <p:sp>
         <p:nvSpPr>
-          <p:cNvPr id="21" name="Text 19"/>
+          <p:cNvPr id="23" name="Text 21"/>
           <p:cNvSpPr txBox="1"/>
           <p:nvPr/>
         </p:nvSpPr>
@@ -11698,7 +12294,7 @@
       </p:sp>
       <p:sp>
         <p:nvSpPr>
-          <p:cNvPr id="22" name="Text 20"/>
+          <p:cNvPr id="24" name="Text 22"/>
           <p:cNvSpPr txBox="1"/>
           <p:nvPr/>
         </p:nvSpPr>
@@ -11723,7 +12319,7 @@
             <a:r>
               <a:rPr lang="en-US" sz="1000" b="1" spc="100" kern="0" dirty="0">
                 <a:solidFill>
-                  <a:srgbClr val="C67A43"/>
+                  <a:srgbClr val="6FA8DC"/>
                 </a:solidFill>
                 <a:latin typeface="Arial" pitchFamily="34" charset="0"/>
                 <a:ea typeface="Arial" pitchFamily="34" charset="-122"/>
@@ -11737,7 +12333,7 @@
       </p:sp>
       <p:sp>
         <p:nvSpPr>
-          <p:cNvPr id="23" name="Text 21"/>
+          <p:cNvPr id="25" name="Text 23"/>
           <p:cNvSpPr txBox="1"/>
           <p:nvPr/>
         </p:nvSpPr>
@@ -11776,7 +12372,7 @@
       </p:sp>
       <p:sp>
         <p:nvSpPr>
-          <p:cNvPr id="24" name="Text 22"/>
+          <p:cNvPr id="26" name="Text 24"/>
           <p:cNvSpPr txBox="1"/>
           <p:nvPr/>
         </p:nvSpPr>
@@ -11801,7 +12397,7 @@
             <a:r>
               <a:rPr lang="en-US" sz="1000" b="1" spc="100" kern="0" dirty="0">
                 <a:solidFill>
-                  <a:srgbClr val="C67A43"/>
+                  <a:srgbClr val="6FA8DC"/>
                 </a:solidFill>
                 <a:latin typeface="Arial" pitchFamily="34" charset="0"/>
                 <a:ea typeface="Arial" pitchFamily="34" charset="-122"/>
@@ -11815,7 +12411,7 @@
       </p:sp>
       <p:sp>
         <p:nvSpPr>
-          <p:cNvPr id="25" name="Text 23"/>
+          <p:cNvPr id="27" name="Text 25"/>
           <p:cNvSpPr txBox="1"/>
           <p:nvPr/>
         </p:nvSpPr>
@@ -11854,7 +12450,7 @@
       </p:sp>
       <p:sp>
         <p:nvSpPr>
-          <p:cNvPr id="26" name="Text 24"/>
+          <p:cNvPr id="28" name="Text 26"/>
           <p:cNvSpPr txBox="1"/>
           <p:nvPr/>
         </p:nvSpPr>
@@ -11879,7 +12475,7 @@
             <a:r>
               <a:rPr lang="en-US" sz="1000" b="1" spc="100" kern="0" dirty="0">
                 <a:solidFill>
-                  <a:srgbClr val="C67A43"/>
+                  <a:srgbClr val="6FA8DC"/>
                 </a:solidFill>
                 <a:latin typeface="Arial" pitchFamily="34" charset="0"/>
                 <a:ea typeface="Arial" pitchFamily="34" charset="-122"/>
@@ -11893,7 +12489,7 @@
       </p:sp>
       <p:sp>
         <p:nvSpPr>
-          <p:cNvPr id="27" name="Text 25"/>
+          <p:cNvPr id="29" name="Text 27"/>
           <p:cNvSpPr txBox="1"/>
           <p:nvPr/>
         </p:nvSpPr>
@@ -11932,7 +12528,7 @@
       </p:sp>
       <p:sp>
         <p:nvSpPr>
-          <p:cNvPr id="28" name="Text 26"/>
+          <p:cNvPr id="30" name="Text 28"/>
           <p:cNvSpPr txBox="1"/>
           <p:nvPr/>
         </p:nvSpPr>
@@ -11947,7 +12543,7 @@
             </a:avLst>
           </a:prstGeom>
           <a:solidFill>
-            <a:srgbClr val="C67A43"/>
+            <a:srgbClr val="00539B"/>
           </a:solidFill>
           <a:ln/>
         </p:spPr>
@@ -11975,7 +12571,7 @@
       </p:sp>
       <p:sp>
         <p:nvSpPr>
-          <p:cNvPr id="29" name="Text 27"/>
+          <p:cNvPr id="31" name="Text 29"/>
           <p:cNvSpPr txBox="1"/>
           <p:nvPr/>
         </p:nvSpPr>
@@ -12000,7 +12596,7 @@
             <a:r>
               <a:rPr lang="en-US" sz="950" dirty="0">
                 <a:solidFill>
-                  <a:srgbClr val="A6ACB3"/>
+                  <a:srgbClr val="9FB4CC"/>
                 </a:solidFill>
                 <a:latin typeface="Arial" pitchFamily="34" charset="0"/>
                 <a:ea typeface="Arial" pitchFamily="34" charset="-122"/>
@@ -12014,7 +12610,7 @@
       </p:sp>
       <p:sp>
         <p:nvSpPr>
-          <p:cNvPr id="30" name="Text 28"/>
+          <p:cNvPr id="32" name="Text 30"/>
           <p:cNvSpPr txBox="1"/>
           <p:nvPr/>
         </p:nvSpPr>
@@ -12039,7 +12635,7 @@
             <a:r>
               <a:rPr lang="en-US" sz="1500" b="1" dirty="0">
                 <a:solidFill>
-                  <a:srgbClr val="C67A43"/>
+                  <a:srgbClr val="6FA8DC"/>
                 </a:solidFill>
                 <a:latin typeface="Arial" pitchFamily="34" charset="0"/>
                 <a:ea typeface="Arial" pitchFamily="34" charset="-122"/>
@@ -12053,14 +12649,14 @@
       </p:sp>
       <p:sp>
         <p:nvSpPr>
-          <p:cNvPr id="31" name="Text 29"/>
+          <p:cNvPr id="33" name="Text 31"/>
           <p:cNvSpPr txBox="1"/>
           <p:nvPr/>
         </p:nvSpPr>
         <p:spPr>
           <a:xfrm>
             <a:off x="548640" y="6510528"/>
-            <a:ext cx="5029200" cy="237744"/>
+            <a:ext cx="3840480" cy="237744"/>
           </a:xfrm>
           <a:prstGeom prst="rect">
             <a:avLst/>
@@ -12078,7 +12674,7 @@
             <a:r>
               <a:rPr lang="en-US" sz="800" dirty="0">
                 <a:solidFill>
-                  <a:srgbClr val="8C9299"/>
+                  <a:srgbClr val="7E95AF"/>
                 </a:solidFill>
                 <a:latin typeface="Arial" pitchFamily="34" charset="0"/>
                 <a:ea typeface="Arial" pitchFamily="34" charset="-122"/>
@@ -12092,14 +12688,14 @@
       </p:sp>
       <p:sp>
         <p:nvSpPr>
-          <p:cNvPr id="32" name="Text 30"/>
-          <p:cNvSpPr txBox="1"/>
-          <p:nvPr/>
-        </p:nvSpPr>
-        <p:spPr>
-          <a:xfrm>
-            <a:off x="6583680" y="6510528"/>
-            <a:ext cx="5056632" cy="237744"/>
+          <p:cNvPr id="34" name="Text 32"/>
+          <p:cNvSpPr txBox="1"/>
+          <p:nvPr/>
+        </p:nvSpPr>
+        <p:spPr>
+          <a:xfrm>
+            <a:off x="4480560" y="6510528"/>
+            <a:ext cx="3227832" cy="237744"/>
           </a:xfrm>
           <a:prstGeom prst="rect">
             <a:avLst/>
@@ -12111,13 +12707,52 @@
           <a:bodyPr wrap="square" lIns="0" tIns="0" rIns="0" bIns="0" rtlCol="0" anchor="ctr"/>
           <a:lstStyle/>
           <a:p>
+            <a:pPr algn="ctr" indent="0" marL="0">
+              <a:buNone/>
+            </a:pPr>
+            <a:r>
+              <a:rPr lang="en-US" sz="800" i="1" dirty="0">
+                <a:solidFill>
+                  <a:srgbClr val="9FB4CC"/>
+                </a:solidFill>
+                <a:latin typeface="Arial" pitchFamily="34" charset="0"/>
+                <a:ea typeface="Arial" pitchFamily="34" charset="-122"/>
+                <a:cs typeface="Arial" pitchFamily="34" charset="-120"/>
+              </a:rPr>
+              <a:t>We deliver power… responsibly.®</a:t>
+            </a:r>
+            <a:endParaRPr lang="en-US" sz="800" dirty="0"/>
+          </a:p>
+        </p:txBody>
+      </p:sp>
+      <p:sp>
+        <p:nvSpPr>
+          <p:cNvPr id="35" name="Text 33"/>
+          <p:cNvSpPr txBox="1"/>
+          <p:nvPr/>
+        </p:nvSpPr>
+        <p:spPr>
+          <a:xfrm>
+            <a:off x="7799832" y="6510528"/>
+            <a:ext cx="3840480" cy="237744"/>
+          </a:xfrm>
+          <a:prstGeom prst="rect">
+            <a:avLst/>
+          </a:prstGeom>
+          <a:noFill/>
+          <a:ln/>
+        </p:spPr>
+        <p:txBody>
+          <a:bodyPr wrap="square" lIns="0" tIns="0" rIns="0" bIns="0" rtlCol="0" anchor="ctr"/>
+          <a:lstStyle/>
+          <a:p>
             <a:pPr algn="r" indent="0" marL="0">
               <a:buNone/>
             </a:pPr>
             <a:r>
               <a:rPr lang="en-US" sz="800" dirty="0">
                 <a:solidFill>
-                  <a:srgbClr val="8C9299"/>
+                  <a:srgbClr val="7E95AF"/>
                 </a:solidFill>
                 <a:latin typeface="Arial" pitchFamily="34" charset="0"/>
                 <a:ea typeface="Arial" pitchFamily="34" charset="-122"/>

</xml_diff>